<commit_message>
Update project presentation files
Replit-Commit-Author: Agent
</commit_message>
<xml_diff>
--- a/projeto/Ubuntu_Linux_1.pptx
+++ b/projeto/Ubuntu_Linux_1.pptx
@@ -1,132 +1,147 @@
 
 <file path=ppt/presentation.xml><?xml version="1.0" encoding="utf-8"?>
-<ns0:presentation xmlns:ns0="http://schemas.openxmlformats.org/presentationml/2006/main" xmlns:ns1="http://schemas.openxmlformats.org/officeDocument/2006/relationships" xmlns:ns2="http://schemas.openxmlformats.org/drawingml/2006/main" saveSubsetFonts="1" autoCompressPictures="0" embedTrueTypeFonts="1">
-  <ns0:sldMasterIdLst>
-    <ns0:sldMasterId id="2147483648" ns1:id="rId1"/>
-  </ns0:sldMasterIdLst>
-  <ns0:sldIdLst>
-    <ns0:sldId id="256" ns1:id="rId7"/>
-    <ns0:sldId id="257" ns1:id="rId8"/>
-    <ns0:sldId id="258" ns1:id="rId9"/>
-    <ns0:sldId id="259" ns1:id="rId10"/>
-    <ns0:sldId id="260" ns1:id="rId11"/>
-    <ns0:sldId id="261" ns1:id="rId12"/>
-    <ns0:sldId id="262" ns1:id="rId13"/>
-    <ns0:sldId id="263" ns1:id="rId14"/>
-    <ns0:sldId id="264" ns1:id="rId15"/>
-    <ns0:sldId id="265" ns1:id="rId16"/>
-    <ns0:sldId id="266" ns1:id="rId17"/>
-    <ns0:sldId id="267" ns1:id="rId18"/>
-  </ns0:sldIdLst>
-  <ns0:sldSz cx="12192000" cy="6858000" type="screen4x3"/>
-  <ns0:notesSz cx="6858000" cy="9144000"/>
-  <ns0:embeddedFontLst>
-    <ns0:embeddedFont>
-      <ns0:font typeface="Inter"/>
-      <ns0:bold ns1:id="rIdFont19"/>
-      <ns0:regular ns1:id="rIdFont20"/>
-    </ns0:embeddedFont>
-    <ns0:embeddedFont>
-      <ns0:font typeface="Ubuntu"/>
-      <ns0:bold ns1:id="rIdFont21"/>
-    </ns0:embeddedFont>
-  </ns0:embeddedFontLst>
-  <ns0:defaultTextStyle>
-    <ns2:defPPr>
-      <ns2:defRPr lang="en-US"/>
-    </ns2:defPPr>
-    <ns2:lvl1pPr marL="0" algn="l" defTabSz="457200" rtl="0" eaLnBrk="1" latinLnBrk="0" hangingPunct="1">
-      <ns2:defRPr sz="1800" kern="1200">
-        <ns2:solidFill>
-          <ns2:schemeClr val="tx1"/>
-        </ns2:solidFill>
-        <ns2:latin typeface="+mn-lt"/>
-        <ns2:ea typeface="+mn-ea"/>
-        <ns2:cs typeface="+mn-cs"/>
-      </ns2:defRPr>
-    </ns2:lvl1pPr>
-    <ns2:lvl2pPr marL="457200" algn="l" defTabSz="457200" rtl="0" eaLnBrk="1" latinLnBrk="0" hangingPunct="1">
-      <ns2:defRPr sz="1800" kern="1200">
-        <ns2:solidFill>
-          <ns2:schemeClr val="tx1"/>
-        </ns2:solidFill>
-        <ns2:latin typeface="+mn-lt"/>
-        <ns2:ea typeface="+mn-ea"/>
-        <ns2:cs typeface="+mn-cs"/>
-      </ns2:defRPr>
-    </ns2:lvl2pPr>
-    <ns2:lvl3pPr marL="914400" algn="l" defTabSz="457200" rtl="0" eaLnBrk="1" latinLnBrk="0" hangingPunct="1">
-      <ns2:defRPr sz="1800" kern="1200">
-        <ns2:solidFill>
-          <ns2:schemeClr val="tx1"/>
-        </ns2:solidFill>
-        <ns2:latin typeface="+mn-lt"/>
-        <ns2:ea typeface="+mn-ea"/>
-        <ns2:cs typeface="+mn-cs"/>
-      </ns2:defRPr>
-    </ns2:lvl3pPr>
-    <ns2:lvl4pPr marL="1371600" algn="l" defTabSz="457200" rtl="0" eaLnBrk="1" latinLnBrk="0" hangingPunct="1">
-      <ns2:defRPr sz="1800" kern="1200">
-        <ns2:solidFill>
-          <ns2:schemeClr val="tx1"/>
-        </ns2:solidFill>
-        <ns2:latin typeface="+mn-lt"/>
-        <ns2:ea typeface="+mn-ea"/>
-        <ns2:cs typeface="+mn-cs"/>
-      </ns2:defRPr>
-    </ns2:lvl4pPr>
-    <ns2:lvl5pPr marL="1828800" algn="l" defTabSz="457200" rtl="0" eaLnBrk="1" latinLnBrk="0" hangingPunct="1">
-      <ns2:defRPr sz="1800" kern="1200">
-        <ns2:solidFill>
-          <ns2:schemeClr val="tx1"/>
-        </ns2:solidFill>
-        <ns2:latin typeface="+mn-lt"/>
-        <ns2:ea typeface="+mn-ea"/>
-        <ns2:cs typeface="+mn-cs"/>
-      </ns2:defRPr>
-    </ns2:lvl5pPr>
-    <ns2:lvl6pPr marL="2286000" algn="l" defTabSz="457200" rtl="0" eaLnBrk="1" latinLnBrk="0" hangingPunct="1">
-      <ns2:defRPr sz="1800" kern="1200">
-        <ns2:solidFill>
-          <ns2:schemeClr val="tx1"/>
-        </ns2:solidFill>
-        <ns2:latin typeface="+mn-lt"/>
-        <ns2:ea typeface="+mn-ea"/>
-        <ns2:cs typeface="+mn-cs"/>
-      </ns2:defRPr>
-    </ns2:lvl6pPr>
-    <ns2:lvl7pPr marL="2743200" algn="l" defTabSz="457200" rtl="0" eaLnBrk="1" latinLnBrk="0" hangingPunct="1">
-      <ns2:defRPr sz="1800" kern="1200">
-        <ns2:solidFill>
-          <ns2:schemeClr val="tx1"/>
-        </ns2:solidFill>
-        <ns2:latin typeface="+mn-lt"/>
-        <ns2:ea typeface="+mn-ea"/>
-        <ns2:cs typeface="+mn-cs"/>
-      </ns2:defRPr>
-    </ns2:lvl7pPr>
-    <ns2:lvl8pPr marL="3200400" algn="l" defTabSz="457200" rtl="0" eaLnBrk="1" latinLnBrk="0" hangingPunct="1">
-      <ns2:defRPr sz="1800" kern="1200">
-        <ns2:solidFill>
-          <ns2:schemeClr val="tx1"/>
-        </ns2:solidFill>
-        <ns2:latin typeface="+mn-lt"/>
-        <ns2:ea typeface="+mn-ea"/>
-        <ns2:cs typeface="+mn-cs"/>
-      </ns2:defRPr>
-    </ns2:lvl8pPr>
-    <ns2:lvl9pPr marL="3657600" algn="l" defTabSz="457200" rtl="0" eaLnBrk="1" latinLnBrk="0" hangingPunct="1">
-      <ns2:defRPr sz="1800" kern="1200">
-        <ns2:solidFill>
-          <ns2:schemeClr val="tx1"/>
-        </ns2:solidFill>
-        <ns2:latin typeface="+mn-lt"/>
-        <ns2:ea typeface="+mn-ea"/>
-        <ns2:cs typeface="+mn-cs"/>
-      </ns2:defRPr>
-    </ns2:lvl9pPr>
-  </ns0:defaultTextStyle>
-</ns0:presentation>
+<p:presentation xmlns:a="http://schemas.openxmlformats.org/drawingml/2006/main" xmlns:r="http://schemas.openxmlformats.org/officeDocument/2006/relationships" xmlns:p="http://schemas.openxmlformats.org/presentationml/2006/main" embedTrueTypeFonts="1" saveSubsetFonts="1" autoCompressPictures="0">
+  <p:sldMasterIdLst>
+    <p:sldMasterId id="2147483648" r:id="rId1"/>
+  </p:sldMasterIdLst>
+  <p:sldIdLst>
+    <p:sldId id="256" r:id="rId2"/>
+    <p:sldId id="257" r:id="rId3"/>
+    <p:sldId id="258" r:id="rId4"/>
+    <p:sldId id="259" r:id="rId5"/>
+    <p:sldId id="260" r:id="rId6"/>
+    <p:sldId id="261" r:id="rId7"/>
+    <p:sldId id="262" r:id="rId8"/>
+    <p:sldId id="263" r:id="rId9"/>
+    <p:sldId id="264" r:id="rId10"/>
+    <p:sldId id="265" r:id="rId11"/>
+    <p:sldId id="266" r:id="rId12"/>
+    <p:sldId id="267" r:id="rId13"/>
+  </p:sldIdLst>
+  <p:sldSz cx="12192000" cy="6858000"/>
+  <p:notesSz cx="6858000" cy="9144000"/>
+  <p:embeddedFontLst>
+    <p:embeddedFont>
+      <p:font typeface="Inter"/>
+      <p:bold r:id="rId14"/>
+    </p:embeddedFont>
+    <p:embeddedFont>
+      <p:font typeface="Ubuntu"/>
+      <p:bold r:id="rId15"/>
+    </p:embeddedFont>
+  </p:embeddedFontLst>
+  <p:defaultTextStyle>
+    <a:defPPr>
+      <a:defRPr lang="en-US"/>
+    </a:defPPr>
+    <a:lvl1pPr marL="0" algn="l" defTabSz="457200" rtl="0" eaLnBrk="1" latinLnBrk="0" hangingPunct="1">
+      <a:defRPr sz="1800" kern="1200">
+        <a:solidFill>
+          <a:schemeClr val="tx1"/>
+        </a:solidFill>
+        <a:latin typeface="+mn-lt"/>
+        <a:ea typeface="+mn-ea"/>
+        <a:cs typeface="+mn-cs"/>
+      </a:defRPr>
+    </a:lvl1pPr>
+    <a:lvl2pPr marL="457200" algn="l" defTabSz="457200" rtl="0" eaLnBrk="1" latinLnBrk="0" hangingPunct="1">
+      <a:defRPr sz="1800" kern="1200">
+        <a:solidFill>
+          <a:schemeClr val="tx1"/>
+        </a:solidFill>
+        <a:latin typeface="+mn-lt"/>
+        <a:ea typeface="+mn-ea"/>
+        <a:cs typeface="+mn-cs"/>
+      </a:defRPr>
+    </a:lvl2pPr>
+    <a:lvl3pPr marL="914400" algn="l" defTabSz="457200" rtl="0" eaLnBrk="1" latinLnBrk="0" hangingPunct="1">
+      <a:defRPr sz="1800" kern="1200">
+        <a:solidFill>
+          <a:schemeClr val="tx1"/>
+        </a:solidFill>
+        <a:latin typeface="+mn-lt"/>
+        <a:ea typeface="+mn-ea"/>
+        <a:cs typeface="+mn-cs"/>
+      </a:defRPr>
+    </a:lvl3pPr>
+    <a:lvl4pPr marL="1371600" algn="l" defTabSz="457200" rtl="0" eaLnBrk="1" latinLnBrk="0" hangingPunct="1">
+      <a:defRPr sz="1800" kern="1200">
+        <a:solidFill>
+          <a:schemeClr val="tx1"/>
+        </a:solidFill>
+        <a:latin typeface="+mn-lt"/>
+        <a:ea typeface="+mn-ea"/>
+        <a:cs typeface="+mn-cs"/>
+      </a:defRPr>
+    </a:lvl4pPr>
+    <a:lvl5pPr marL="1828800" algn="l" defTabSz="457200" rtl="0" eaLnBrk="1" latinLnBrk="0" hangingPunct="1">
+      <a:defRPr sz="1800" kern="1200">
+        <a:solidFill>
+          <a:schemeClr val="tx1"/>
+        </a:solidFill>
+        <a:latin typeface="+mn-lt"/>
+        <a:ea typeface="+mn-ea"/>
+        <a:cs typeface="+mn-cs"/>
+      </a:defRPr>
+    </a:lvl5pPr>
+    <a:lvl6pPr marL="2286000" algn="l" defTabSz="457200" rtl="0" eaLnBrk="1" latinLnBrk="0" hangingPunct="1">
+      <a:defRPr sz="1800" kern="1200">
+        <a:solidFill>
+          <a:schemeClr val="tx1"/>
+        </a:solidFill>
+        <a:latin typeface="+mn-lt"/>
+        <a:ea typeface="+mn-ea"/>
+        <a:cs typeface="+mn-cs"/>
+      </a:defRPr>
+    </a:lvl6pPr>
+    <a:lvl7pPr marL="2743200" algn="l" defTabSz="457200" rtl="0" eaLnBrk="1" latinLnBrk="0" hangingPunct="1">
+      <a:defRPr sz="1800" kern="1200">
+        <a:solidFill>
+          <a:schemeClr val="tx1"/>
+        </a:solidFill>
+        <a:latin typeface="+mn-lt"/>
+        <a:ea typeface="+mn-ea"/>
+        <a:cs typeface="+mn-cs"/>
+      </a:defRPr>
+    </a:lvl7pPr>
+    <a:lvl8pPr marL="3200400" algn="l" defTabSz="457200" rtl="0" eaLnBrk="1" latinLnBrk="0" hangingPunct="1">
+      <a:defRPr sz="1800" kern="1200">
+        <a:solidFill>
+          <a:schemeClr val="tx1"/>
+        </a:solidFill>
+        <a:latin typeface="+mn-lt"/>
+        <a:ea typeface="+mn-ea"/>
+        <a:cs typeface="+mn-cs"/>
+      </a:defRPr>
+    </a:lvl8pPr>
+    <a:lvl9pPr marL="3657600" algn="l" defTabSz="457200" rtl="0" eaLnBrk="1" latinLnBrk="0" hangingPunct="1">
+      <a:defRPr sz="1800" kern="1200">
+        <a:solidFill>
+          <a:schemeClr val="tx1"/>
+        </a:solidFill>
+        <a:latin typeface="+mn-lt"/>
+        <a:ea typeface="+mn-ea"/>
+        <a:cs typeface="+mn-cs"/>
+      </a:defRPr>
+    </a:lvl9pPr>
+  </p:defaultTextStyle>
+  <p:extLst>
+    <p:ext uri="{EFAFB233-063F-42B5-8137-9DF3F51BA10A}">
+      <p15:sldGuideLst xmlns:p15="http://schemas.microsoft.com/office/powerpoint/2012/main">
+        <p15:guide id="1" orient="horz" pos="2160">
+          <p15:clr>
+            <a:srgbClr val="A4A3A4"/>
+          </p15:clr>
+        </p15:guide>
+        <p15:guide id="2" pos="2880">
+          <p15:clr>
+            <a:srgbClr val="A4A3A4"/>
+          </p15:clr>
+        </p15:guide>
+      </p15:sldGuideLst>
+    </p:ext>
+  </p:extLst>
+</p:presentation>
 </file>
 
 <file path=ppt/slideLayouts/slideLayout1.xml><?xml version="1.0" encoding="utf-8"?>
@@ -167,10 +182,9 @@
           <a:lstStyle/>
           <a:p>
             <a:r>
-              <a:rPr lang="en-US" smtClean="0"/>
+              <a:rPr lang="en-US"/>
               <a:t>Click to edit Master title style</a:t>
             </a:r>
-            <a:endParaRPr lang="en-US"/>
           </a:p>
         </p:txBody>
       </p:sp>
@@ -286,10 +300,9 @@
           </a:lstStyle>
           <a:p>
             <a:r>
-              <a:rPr lang="en-US" smtClean="0"/>
+              <a:rPr lang="en-US"/>
               <a:t>Click to edit Master subtitle style</a:t>
             </a:r>
-            <a:endParaRPr lang="en-US"/>
           </a:p>
         </p:txBody>
       </p:sp>
@@ -310,7 +323,7 @@
           <a:p>
             <a:fld id="{5BCAD085-E8A6-8845-BD4E-CB4CCA059FC4}" type="datetimeFigureOut">
               <a:rPr lang="en-US" smtClean="0"/>
-              <a:t>1/27/13</a:t>
+              <a:t>10/12/2026</a:t>
             </a:fld>
             <a:endParaRPr lang="en-US"/>
           </a:p>
@@ -352,7 +365,7 @@
           <a:p>
             <a:fld id="{C1FF6DA9-008F-8B48-92A6-B652298478BF}" type="slidenum">
               <a:rPr lang="en-US" smtClean="0"/>
-              <a:t>‹#›</a:t>
+              <a:t>‹nº›</a:t>
             </a:fld>
             <a:endParaRPr lang="en-US"/>
           </a:p>
@@ -404,10 +417,9 @@
           <a:lstStyle/>
           <a:p>
             <a:r>
-              <a:rPr lang="en-US" smtClean="0"/>
+              <a:rPr lang="en-US"/>
               <a:t>Click to edit Master title style</a:t>
             </a:r>
-            <a:endParaRPr lang="en-US"/>
           </a:p>
         </p:txBody>
       </p:sp>
@@ -428,38 +440,37 @@
           <a:p>
             <a:pPr lvl="0"/>
             <a:r>
-              <a:rPr lang="en-US" smtClean="0"/>
+              <a:rPr lang="en-US"/>
               <a:t>Click to edit Master text styles</a:t>
             </a:r>
           </a:p>
           <a:p>
             <a:pPr lvl="1"/>
             <a:r>
-              <a:rPr lang="en-US" smtClean="0"/>
+              <a:rPr lang="en-US"/>
               <a:t>Second level</a:t>
             </a:r>
           </a:p>
           <a:p>
             <a:pPr lvl="2"/>
             <a:r>
-              <a:rPr lang="en-US" smtClean="0"/>
+              <a:rPr lang="en-US"/>
               <a:t>Third level</a:t>
             </a:r>
           </a:p>
           <a:p>
             <a:pPr lvl="3"/>
             <a:r>
-              <a:rPr lang="en-US" smtClean="0"/>
+              <a:rPr lang="en-US"/>
               <a:t>Fourth level</a:t>
             </a:r>
           </a:p>
           <a:p>
             <a:pPr lvl="4"/>
             <a:r>
-              <a:rPr lang="en-US" smtClean="0"/>
+              <a:rPr lang="en-US"/>
               <a:t>Fifth level</a:t>
             </a:r>
-            <a:endParaRPr lang="en-US"/>
           </a:p>
         </p:txBody>
       </p:sp>
@@ -480,7 +491,7 @@
           <a:p>
             <a:fld id="{5BCAD085-E8A6-8845-BD4E-CB4CCA059FC4}" type="datetimeFigureOut">
               <a:rPr lang="en-US" smtClean="0"/>
-              <a:t>1/27/13</a:t>
+              <a:t>10/12/2026</a:t>
             </a:fld>
             <a:endParaRPr lang="en-US"/>
           </a:p>
@@ -522,7 +533,7 @@
           <a:p>
             <a:fld id="{C1FF6DA9-008F-8B48-92A6-B652298478BF}" type="slidenum">
               <a:rPr lang="en-US" smtClean="0"/>
-              <a:t>‹#›</a:t>
+              <a:t>‹nº›</a:t>
             </a:fld>
             <a:endParaRPr lang="en-US"/>
           </a:p>
@@ -579,10 +590,9 @@
           <a:lstStyle/>
           <a:p>
             <a:r>
-              <a:rPr lang="en-US" smtClean="0"/>
+              <a:rPr lang="en-US"/>
               <a:t>Click to edit Master title style</a:t>
             </a:r>
-            <a:endParaRPr lang="en-US"/>
           </a:p>
         </p:txBody>
       </p:sp>
@@ -608,38 +618,37 @@
           <a:p>
             <a:pPr lvl="0"/>
             <a:r>
-              <a:rPr lang="en-US" smtClean="0"/>
+              <a:rPr lang="en-US"/>
               <a:t>Click to edit Master text styles</a:t>
             </a:r>
           </a:p>
           <a:p>
             <a:pPr lvl="1"/>
             <a:r>
-              <a:rPr lang="en-US" smtClean="0"/>
+              <a:rPr lang="en-US"/>
               <a:t>Second level</a:t>
             </a:r>
           </a:p>
           <a:p>
             <a:pPr lvl="2"/>
             <a:r>
-              <a:rPr lang="en-US" smtClean="0"/>
+              <a:rPr lang="en-US"/>
               <a:t>Third level</a:t>
             </a:r>
           </a:p>
           <a:p>
             <a:pPr lvl="3"/>
             <a:r>
-              <a:rPr lang="en-US" smtClean="0"/>
+              <a:rPr lang="en-US"/>
               <a:t>Fourth level</a:t>
             </a:r>
           </a:p>
           <a:p>
             <a:pPr lvl="4"/>
             <a:r>
-              <a:rPr lang="en-US" smtClean="0"/>
+              <a:rPr lang="en-US"/>
               <a:t>Fifth level</a:t>
             </a:r>
-            <a:endParaRPr lang="en-US"/>
           </a:p>
         </p:txBody>
       </p:sp>
@@ -660,7 +669,7 @@
           <a:p>
             <a:fld id="{5BCAD085-E8A6-8845-BD4E-CB4CCA059FC4}" type="datetimeFigureOut">
               <a:rPr lang="en-US" smtClean="0"/>
-              <a:t>1/27/13</a:t>
+              <a:t>10/12/2026</a:t>
             </a:fld>
             <a:endParaRPr lang="en-US"/>
           </a:p>
@@ -702,7 +711,7 @@
           <a:p>
             <a:fld id="{C1FF6DA9-008F-8B48-92A6-B652298478BF}" type="slidenum">
               <a:rPr lang="en-US" smtClean="0"/>
-              <a:t>‹#›</a:t>
+              <a:t>‹nº›</a:t>
             </a:fld>
             <a:endParaRPr lang="en-US"/>
           </a:p>
@@ -754,10 +763,9 @@
           <a:lstStyle/>
           <a:p>
             <a:r>
-              <a:rPr lang="en-US" smtClean="0"/>
+              <a:rPr lang="en-US"/>
               <a:t>Click to edit Master title style</a:t>
             </a:r>
-            <a:endParaRPr lang="en-US"/>
           </a:p>
         </p:txBody>
       </p:sp>
@@ -778,38 +786,37 @@
           <a:p>
             <a:pPr lvl="0"/>
             <a:r>
-              <a:rPr lang="en-US" smtClean="0"/>
+              <a:rPr lang="en-US"/>
               <a:t>Click to edit Master text styles</a:t>
             </a:r>
           </a:p>
           <a:p>
             <a:pPr lvl="1"/>
             <a:r>
-              <a:rPr lang="en-US" smtClean="0"/>
+              <a:rPr lang="en-US"/>
               <a:t>Second level</a:t>
             </a:r>
           </a:p>
           <a:p>
             <a:pPr lvl="2"/>
             <a:r>
-              <a:rPr lang="en-US" smtClean="0"/>
+              <a:rPr lang="en-US"/>
               <a:t>Third level</a:t>
             </a:r>
           </a:p>
           <a:p>
             <a:pPr lvl="3"/>
             <a:r>
-              <a:rPr lang="en-US" smtClean="0"/>
+              <a:rPr lang="en-US"/>
               <a:t>Fourth level</a:t>
             </a:r>
           </a:p>
           <a:p>
             <a:pPr lvl="4"/>
             <a:r>
-              <a:rPr lang="en-US" smtClean="0"/>
+              <a:rPr lang="en-US"/>
               <a:t>Fifth level</a:t>
             </a:r>
-            <a:endParaRPr lang="en-US"/>
           </a:p>
         </p:txBody>
       </p:sp>
@@ -830,7 +837,7 @@
           <a:p>
             <a:fld id="{5BCAD085-E8A6-8845-BD4E-CB4CCA059FC4}" type="datetimeFigureOut">
               <a:rPr lang="en-US" smtClean="0"/>
-              <a:t>1/27/13</a:t>
+              <a:t>10/12/2026</a:t>
             </a:fld>
             <a:endParaRPr lang="en-US"/>
           </a:p>
@@ -872,7 +879,7 @@
           <a:p>
             <a:fld id="{C1FF6DA9-008F-8B48-92A6-B652298478BF}" type="slidenum">
               <a:rPr lang="en-US" smtClean="0"/>
-              <a:t>‹#›</a:t>
+              <a:t>‹nº›</a:t>
             </a:fld>
             <a:endParaRPr lang="en-US"/>
           </a:p>
@@ -933,10 +940,9 @@
           </a:lstStyle>
           <a:p>
             <a:r>
-              <a:rPr lang="en-US" smtClean="0"/>
+              <a:rPr lang="en-US"/>
               <a:t>Click to edit Master title style</a:t>
             </a:r>
-            <a:endParaRPr lang="en-US"/>
           </a:p>
         </p:txBody>
       </p:sp>
@@ -1053,7 +1059,7 @@
           <a:p>
             <a:pPr lvl="0"/>
             <a:r>
-              <a:rPr lang="en-US" smtClean="0"/>
+              <a:rPr lang="en-US"/>
               <a:t>Click to edit Master text styles</a:t>
             </a:r>
           </a:p>
@@ -1076,7 +1082,7 @@
           <a:p>
             <a:fld id="{5BCAD085-E8A6-8845-BD4E-CB4CCA059FC4}" type="datetimeFigureOut">
               <a:rPr lang="en-US" smtClean="0"/>
-              <a:t>1/27/13</a:t>
+              <a:t>10/12/2026</a:t>
             </a:fld>
             <a:endParaRPr lang="en-US"/>
           </a:p>
@@ -1118,7 +1124,7 @@
           <a:p>
             <a:fld id="{C1FF6DA9-008F-8B48-92A6-B652298478BF}" type="slidenum">
               <a:rPr lang="en-US" smtClean="0"/>
-              <a:t>‹#›</a:t>
+              <a:t>‹nº›</a:t>
             </a:fld>
             <a:endParaRPr lang="en-US"/>
           </a:p>
@@ -1170,10 +1176,9 @@
           <a:lstStyle/>
           <a:p>
             <a:r>
-              <a:rPr lang="en-US" smtClean="0"/>
+              <a:rPr lang="en-US"/>
               <a:t>Click to edit Master title style</a:t>
             </a:r>
-            <a:endParaRPr lang="en-US"/>
           </a:p>
         </p:txBody>
       </p:sp>
@@ -1227,38 +1232,37 @@
           <a:p>
             <a:pPr lvl="0"/>
             <a:r>
-              <a:rPr lang="en-US" smtClean="0"/>
+              <a:rPr lang="en-US"/>
               <a:t>Click to edit Master text styles</a:t>
             </a:r>
           </a:p>
           <a:p>
             <a:pPr lvl="1"/>
             <a:r>
-              <a:rPr lang="en-US" smtClean="0"/>
+              <a:rPr lang="en-US"/>
               <a:t>Second level</a:t>
             </a:r>
           </a:p>
           <a:p>
             <a:pPr lvl="2"/>
             <a:r>
-              <a:rPr lang="en-US" smtClean="0"/>
+              <a:rPr lang="en-US"/>
               <a:t>Third level</a:t>
             </a:r>
           </a:p>
           <a:p>
             <a:pPr lvl="3"/>
             <a:r>
-              <a:rPr lang="en-US" smtClean="0"/>
+              <a:rPr lang="en-US"/>
               <a:t>Fourth level</a:t>
             </a:r>
           </a:p>
           <a:p>
             <a:pPr lvl="4"/>
             <a:r>
-              <a:rPr lang="en-US" smtClean="0"/>
+              <a:rPr lang="en-US"/>
               <a:t>Fifth level</a:t>
             </a:r>
-            <a:endParaRPr lang="en-US"/>
           </a:p>
         </p:txBody>
       </p:sp>
@@ -1312,38 +1316,37 @@
           <a:p>
             <a:pPr lvl="0"/>
             <a:r>
-              <a:rPr lang="en-US" smtClean="0"/>
+              <a:rPr lang="en-US"/>
               <a:t>Click to edit Master text styles</a:t>
             </a:r>
           </a:p>
           <a:p>
             <a:pPr lvl="1"/>
             <a:r>
-              <a:rPr lang="en-US" smtClean="0"/>
+              <a:rPr lang="en-US"/>
               <a:t>Second level</a:t>
             </a:r>
           </a:p>
           <a:p>
             <a:pPr lvl="2"/>
             <a:r>
-              <a:rPr lang="en-US" smtClean="0"/>
+              <a:rPr lang="en-US"/>
               <a:t>Third level</a:t>
             </a:r>
           </a:p>
           <a:p>
             <a:pPr lvl="3"/>
             <a:r>
-              <a:rPr lang="en-US" smtClean="0"/>
+              <a:rPr lang="en-US"/>
               <a:t>Fourth level</a:t>
             </a:r>
           </a:p>
           <a:p>
             <a:pPr lvl="4"/>
             <a:r>
-              <a:rPr lang="en-US" smtClean="0"/>
+              <a:rPr lang="en-US"/>
               <a:t>Fifth level</a:t>
             </a:r>
-            <a:endParaRPr lang="en-US"/>
           </a:p>
         </p:txBody>
       </p:sp>
@@ -1364,7 +1367,7 @@
           <a:p>
             <a:fld id="{5BCAD085-E8A6-8845-BD4E-CB4CCA059FC4}" type="datetimeFigureOut">
               <a:rPr lang="en-US" smtClean="0"/>
-              <a:t>1/27/13</a:t>
+              <a:t>10/12/2026</a:t>
             </a:fld>
             <a:endParaRPr lang="en-US"/>
           </a:p>
@@ -1406,7 +1409,7 @@
           <a:p>
             <a:fld id="{C1FF6DA9-008F-8B48-92A6-B652298478BF}" type="slidenum">
               <a:rPr lang="en-US" smtClean="0"/>
-              <a:t>‹#›</a:t>
+              <a:t>‹nº›</a:t>
             </a:fld>
             <a:endParaRPr lang="en-US"/>
           </a:p>
@@ -1462,10 +1465,9 @@
           </a:lstStyle>
           <a:p>
             <a:r>
-              <a:rPr lang="en-US" smtClean="0"/>
+              <a:rPr lang="en-US"/>
               <a:t>Click to edit Master title style</a:t>
             </a:r>
-            <a:endParaRPr lang="en-US"/>
           </a:p>
         </p:txBody>
       </p:sp>
@@ -1528,7 +1530,7 @@
           <a:p>
             <a:pPr lvl="0"/>
             <a:r>
-              <a:rPr lang="en-US" smtClean="0"/>
+              <a:rPr lang="en-US"/>
               <a:t>Click to edit Master text styles</a:t>
             </a:r>
           </a:p>
@@ -1584,38 +1586,37 @@
           <a:p>
             <a:pPr lvl="0"/>
             <a:r>
-              <a:rPr lang="en-US" smtClean="0"/>
+              <a:rPr lang="en-US"/>
               <a:t>Click to edit Master text styles</a:t>
             </a:r>
           </a:p>
           <a:p>
             <a:pPr lvl="1"/>
             <a:r>
-              <a:rPr lang="en-US" smtClean="0"/>
+              <a:rPr lang="en-US"/>
               <a:t>Second level</a:t>
             </a:r>
           </a:p>
           <a:p>
             <a:pPr lvl="2"/>
             <a:r>
-              <a:rPr lang="en-US" smtClean="0"/>
+              <a:rPr lang="en-US"/>
               <a:t>Third level</a:t>
             </a:r>
           </a:p>
           <a:p>
             <a:pPr lvl="3"/>
             <a:r>
-              <a:rPr lang="en-US" smtClean="0"/>
+              <a:rPr lang="en-US"/>
               <a:t>Fourth level</a:t>
             </a:r>
           </a:p>
           <a:p>
             <a:pPr lvl="4"/>
             <a:r>
-              <a:rPr lang="en-US" smtClean="0"/>
+              <a:rPr lang="en-US"/>
               <a:t>Fifth level</a:t>
             </a:r>
-            <a:endParaRPr lang="en-US"/>
           </a:p>
         </p:txBody>
       </p:sp>
@@ -1678,7 +1679,7 @@
           <a:p>
             <a:pPr lvl="0"/>
             <a:r>
-              <a:rPr lang="en-US" smtClean="0"/>
+              <a:rPr lang="en-US"/>
               <a:t>Click to edit Master text styles</a:t>
             </a:r>
           </a:p>
@@ -1734,38 +1735,37 @@
           <a:p>
             <a:pPr lvl="0"/>
             <a:r>
-              <a:rPr lang="en-US" smtClean="0"/>
+              <a:rPr lang="en-US"/>
               <a:t>Click to edit Master text styles</a:t>
             </a:r>
           </a:p>
           <a:p>
             <a:pPr lvl="1"/>
             <a:r>
-              <a:rPr lang="en-US" smtClean="0"/>
+              <a:rPr lang="en-US"/>
               <a:t>Second level</a:t>
             </a:r>
           </a:p>
           <a:p>
             <a:pPr lvl="2"/>
             <a:r>
-              <a:rPr lang="en-US" smtClean="0"/>
+              <a:rPr lang="en-US"/>
               <a:t>Third level</a:t>
             </a:r>
           </a:p>
           <a:p>
             <a:pPr lvl="3"/>
             <a:r>
-              <a:rPr lang="en-US" smtClean="0"/>
+              <a:rPr lang="en-US"/>
               <a:t>Fourth level</a:t>
             </a:r>
           </a:p>
           <a:p>
             <a:pPr lvl="4"/>
             <a:r>
-              <a:rPr lang="en-US" smtClean="0"/>
+              <a:rPr lang="en-US"/>
               <a:t>Fifth level</a:t>
             </a:r>
-            <a:endParaRPr lang="en-US"/>
           </a:p>
         </p:txBody>
       </p:sp>
@@ -1786,7 +1786,7 @@
           <a:p>
             <a:fld id="{5BCAD085-E8A6-8845-BD4E-CB4CCA059FC4}" type="datetimeFigureOut">
               <a:rPr lang="en-US" smtClean="0"/>
-              <a:t>1/27/13</a:t>
+              <a:t>10/12/2026</a:t>
             </a:fld>
             <a:endParaRPr lang="en-US"/>
           </a:p>
@@ -1828,7 +1828,7 @@
           <a:p>
             <a:fld id="{C1FF6DA9-008F-8B48-92A6-B652298478BF}" type="slidenum">
               <a:rPr lang="en-US" smtClean="0"/>
-              <a:t>‹#›</a:t>
+              <a:t>‹nº›</a:t>
             </a:fld>
             <a:endParaRPr lang="en-US"/>
           </a:p>
@@ -1880,10 +1880,9 @@
           <a:lstStyle/>
           <a:p>
             <a:r>
-              <a:rPr lang="en-US" smtClean="0"/>
+              <a:rPr lang="en-US"/>
               <a:t>Click to edit Master title style</a:t>
             </a:r>
-            <a:endParaRPr lang="en-US"/>
           </a:p>
         </p:txBody>
       </p:sp>
@@ -1904,7 +1903,7 @@
           <a:p>
             <a:fld id="{5BCAD085-E8A6-8845-BD4E-CB4CCA059FC4}" type="datetimeFigureOut">
               <a:rPr lang="en-US" smtClean="0"/>
-              <a:t>1/27/13</a:t>
+              <a:t>10/12/2026</a:t>
             </a:fld>
             <a:endParaRPr lang="en-US"/>
           </a:p>
@@ -1946,7 +1945,7 @@
           <a:p>
             <a:fld id="{C1FF6DA9-008F-8B48-92A6-B652298478BF}" type="slidenum">
               <a:rPr lang="en-US" smtClean="0"/>
-              <a:t>‹#›</a:t>
+              <a:t>‹nº›</a:t>
             </a:fld>
             <a:endParaRPr lang="en-US"/>
           </a:p>
@@ -1999,7 +1998,7 @@
           <a:p>
             <a:fld id="{5BCAD085-E8A6-8845-BD4E-CB4CCA059FC4}" type="datetimeFigureOut">
               <a:rPr lang="en-US" smtClean="0"/>
-              <a:t>1/27/13</a:t>
+              <a:t>10/12/2026</a:t>
             </a:fld>
             <a:endParaRPr lang="en-US"/>
           </a:p>
@@ -2041,7 +2040,7 @@
           <a:p>
             <a:fld id="{C1FF6DA9-008F-8B48-92A6-B652298478BF}" type="slidenum">
               <a:rPr lang="en-US" smtClean="0"/>
-              <a:t>‹#›</a:t>
+              <a:t>‹nº›</a:t>
             </a:fld>
             <a:endParaRPr lang="en-US"/>
           </a:p>
@@ -2102,10 +2101,9 @@
           </a:lstStyle>
           <a:p>
             <a:r>
-              <a:rPr lang="en-US" smtClean="0"/>
+              <a:rPr lang="en-US"/>
               <a:t>Click to edit Master title style</a:t>
             </a:r>
-            <a:endParaRPr lang="en-US"/>
           </a:p>
         </p:txBody>
       </p:sp>
@@ -2159,38 +2157,37 @@
           <a:p>
             <a:pPr lvl="0"/>
             <a:r>
-              <a:rPr lang="en-US" smtClean="0"/>
+              <a:rPr lang="en-US"/>
               <a:t>Click to edit Master text styles</a:t>
             </a:r>
           </a:p>
           <a:p>
             <a:pPr lvl="1"/>
             <a:r>
-              <a:rPr lang="en-US" smtClean="0"/>
+              <a:rPr lang="en-US"/>
               <a:t>Second level</a:t>
             </a:r>
           </a:p>
           <a:p>
             <a:pPr lvl="2"/>
             <a:r>
-              <a:rPr lang="en-US" smtClean="0"/>
+              <a:rPr lang="en-US"/>
               <a:t>Third level</a:t>
             </a:r>
           </a:p>
           <a:p>
             <a:pPr lvl="3"/>
             <a:r>
-              <a:rPr lang="en-US" smtClean="0"/>
+              <a:rPr lang="en-US"/>
               <a:t>Fourth level</a:t>
             </a:r>
           </a:p>
           <a:p>
             <a:pPr lvl="4"/>
             <a:r>
-              <a:rPr lang="en-US" smtClean="0"/>
+              <a:rPr lang="en-US"/>
               <a:t>Fifth level</a:t>
             </a:r>
-            <a:endParaRPr lang="en-US"/>
           </a:p>
         </p:txBody>
       </p:sp>
@@ -2253,7 +2250,7 @@
           <a:p>
             <a:pPr lvl="0"/>
             <a:r>
-              <a:rPr lang="en-US" smtClean="0"/>
+              <a:rPr lang="en-US"/>
               <a:t>Click to edit Master text styles</a:t>
             </a:r>
           </a:p>
@@ -2276,7 +2273,7 @@
           <a:p>
             <a:fld id="{5BCAD085-E8A6-8845-BD4E-CB4CCA059FC4}" type="datetimeFigureOut">
               <a:rPr lang="en-US" smtClean="0"/>
-              <a:t>1/27/13</a:t>
+              <a:t>10/12/2026</a:t>
             </a:fld>
             <a:endParaRPr lang="en-US"/>
           </a:p>
@@ -2318,7 +2315,7 @@
           <a:p>
             <a:fld id="{C1FF6DA9-008F-8B48-92A6-B652298478BF}" type="slidenum">
               <a:rPr lang="en-US" smtClean="0"/>
-              <a:t>‹#›</a:t>
+              <a:t>‹nº›</a:t>
             </a:fld>
             <a:endParaRPr lang="en-US"/>
           </a:p>
@@ -2379,10 +2376,9 @@
           </a:lstStyle>
           <a:p>
             <a:r>
-              <a:rPr lang="en-US" smtClean="0"/>
+              <a:rPr lang="en-US"/>
               <a:t>Click to edit Master title style</a:t>
             </a:r>
-            <a:endParaRPr lang="en-US"/>
           </a:p>
         </p:txBody>
       </p:sp>
@@ -2506,7 +2502,7 @@
           <a:p>
             <a:pPr lvl="0"/>
             <a:r>
-              <a:rPr lang="en-US" smtClean="0"/>
+              <a:rPr lang="en-US"/>
               <a:t>Click to edit Master text styles</a:t>
             </a:r>
           </a:p>
@@ -2529,7 +2525,7 @@
           <a:p>
             <a:fld id="{5BCAD085-E8A6-8845-BD4E-CB4CCA059FC4}" type="datetimeFigureOut">
               <a:rPr lang="en-US" smtClean="0"/>
-              <a:t>1/27/13</a:t>
+              <a:t>10/12/2026</a:t>
             </a:fld>
             <a:endParaRPr lang="en-US"/>
           </a:p>
@@ -2571,7 +2567,7 @@
           <a:p>
             <a:fld id="{C1FF6DA9-008F-8B48-92A6-B652298478BF}" type="slidenum">
               <a:rPr lang="en-US" smtClean="0"/>
-              <a:t>‹#›</a:t>
+              <a:t>‹nº›</a:t>
             </a:fld>
             <a:endParaRPr lang="en-US"/>
           </a:p>
@@ -2638,10 +2634,9 @@
           <a:lstStyle/>
           <a:p>
             <a:r>
-              <a:rPr lang="en-US" smtClean="0"/>
+              <a:rPr lang="en-US"/>
               <a:t>Click to edit Master title style</a:t>
             </a:r>
-            <a:endParaRPr lang="en-US"/>
           </a:p>
         </p:txBody>
       </p:sp>
@@ -2672,38 +2667,37 @@
           <a:p>
             <a:pPr lvl="0"/>
             <a:r>
-              <a:rPr lang="en-US" smtClean="0"/>
+              <a:rPr lang="en-US"/>
               <a:t>Click to edit Master text styles</a:t>
             </a:r>
           </a:p>
           <a:p>
             <a:pPr lvl="1"/>
             <a:r>
-              <a:rPr lang="en-US" smtClean="0"/>
+              <a:rPr lang="en-US"/>
               <a:t>Second level</a:t>
             </a:r>
           </a:p>
           <a:p>
             <a:pPr lvl="2"/>
             <a:r>
-              <a:rPr lang="en-US" smtClean="0"/>
+              <a:rPr lang="en-US"/>
               <a:t>Third level</a:t>
             </a:r>
           </a:p>
           <a:p>
             <a:pPr lvl="3"/>
             <a:r>
-              <a:rPr lang="en-US" smtClean="0"/>
+              <a:rPr lang="en-US"/>
               <a:t>Fourth level</a:t>
             </a:r>
           </a:p>
           <a:p>
             <a:pPr lvl="4"/>
             <a:r>
-              <a:rPr lang="en-US" smtClean="0"/>
+              <a:rPr lang="en-US"/>
               <a:t>Fifth level</a:t>
             </a:r>
-            <a:endParaRPr lang="en-US"/>
           </a:p>
         </p:txBody>
       </p:sp>
@@ -2742,7 +2736,7 @@
           <a:p>
             <a:fld id="{5BCAD085-E8A6-8845-BD4E-CB4CCA059FC4}" type="datetimeFigureOut">
               <a:rPr lang="en-US" smtClean="0"/>
-              <a:t>1/27/13</a:t>
+              <a:t>10/12/2026</a:t>
             </a:fld>
             <a:endParaRPr lang="en-US"/>
           </a:p>
@@ -2820,7 +2814,7 @@
           <a:p>
             <a:fld id="{C1FF6DA9-008F-8B48-92A6-B652298478BF}" type="slidenum">
               <a:rPr lang="en-US" smtClean="0"/>
-              <a:t>‹#›</a:t>
+              <a:t>‹nº›</a:t>
             </a:fld>
             <a:endParaRPr lang="en-US"/>
           </a:p>
@@ -3101,7 +3095,7 @@
 </file>
 
 <file path=ppt/slides/slide1.xml><?xml version="1.0" encoding="utf-8"?>
-<p:sld xmlns:a="http://schemas.openxmlformats.org/drawingml/2006/main" xmlns:p="http://schemas.openxmlformats.org/presentationml/2006/main" xmlns:r="http://schemas.openxmlformats.org/officeDocument/2006/relationships">
+<p:sld xmlns:a="http://schemas.openxmlformats.org/drawingml/2006/main" xmlns:r="http://schemas.openxmlformats.org/officeDocument/2006/relationships" xmlns:p="http://schemas.openxmlformats.org/presentationml/2006/main">
   <p:cSld>
     <p:bg>
       <p:bgPr>
@@ -3117,7 +3111,14 @@
         <p:cNvGrpSpPr/>
         <p:nvPr/>
       </p:nvGrpSpPr>
-      <p:grpSpPr/>
+      <p:grpSpPr>
+        <a:xfrm>
+          <a:off x="0" y="0"/>
+          <a:ext cx="0" cy="0"/>
+          <a:chOff x="0" y="0"/>
+          <a:chExt cx="0" cy="0"/>
+        </a:xfrm>
+      </p:grpSpPr>
       <p:sp>
         <p:nvSpPr>
           <p:cNvPr id="2" name="Rounded Rectangle 1"/>
@@ -3161,6 +3162,7 @@
           <a:lstStyle/>
           <a:p>
             <a:pPr algn="ctr"/>
+            <a:endParaRPr/>
           </a:p>
         </p:txBody>
       </p:sp>
@@ -3181,14 +3183,14 @@
           <a:noFill/>
         </p:spPr>
         <p:txBody>
-          <a:bodyPr wrap="none" lIns="0" rIns="0" tIns="0" bIns="0" anchor="t">
+          <a:bodyPr wrap="none" lIns="0" tIns="0" rIns="0" bIns="0" anchor="t">
             <a:spAutoFit/>
           </a:bodyPr>
           <a:lstStyle/>
           <a:p>
             <a:pPr algn="l"/>
             <a:r>
-              <a:rPr b="1" sz="1200" i="0" u="none">
+              <a:rPr sz="1200" b="1" i="0" u="none">
                 <a:solidFill>
                   <a:srgbClr val="E95420"/>
                 </a:solidFill>
@@ -3208,15 +3210,15 @@
         <p:spPr>
           <a:xfrm>
             <a:off x="609600" y="2738437"/>
-            <a:ext cx="10626328" cy="613320"/>
-          </a:xfrm>
-          <a:prstGeom prst="rect">
-            <a:avLst/>
-          </a:prstGeom>
-          <a:noFill/>
-        </p:spPr>
-        <p:txBody>
-          <a:bodyPr wrap="none" lIns="0" rIns="0" tIns="0" bIns="0" anchor="t">
+            <a:ext cx="6070573" cy="615553"/>
+          </a:xfrm>
+          <a:prstGeom prst="rect">
+            <a:avLst/>
+          </a:prstGeom>
+          <a:noFill/>
+        </p:spPr>
+        <p:txBody>
+          <a:bodyPr wrap="none" lIns="0" tIns="0" rIns="0" bIns="0" anchor="t">
             <a:spAutoFit/>
           </a:bodyPr>
           <a:lstStyle/>
@@ -3227,14 +3229,38 @@
               </a:lnSpc>
             </a:pPr>
             <a:r>
-              <a:rPr b="1" sz="4200" i="0" u="none">
+              <a:rPr sz="4200" b="1" i="0" u="none" dirty="0" err="1">
                 <a:solidFill>
                   <a:srgbClr val="FFFFFF"/>
                 </a:solidFill>
                 <a:latin typeface="Ubuntu"/>
               </a:rPr>
-              <a:t>Descubra o Ubuntu Linux</a:t>
-            </a:r>
+              <a:t>Descubra</a:t>
+            </a:r>
+            <a:r>
+              <a:rPr sz="4200" b="1" i="0" u="none" dirty="0">
+                <a:solidFill>
+                  <a:srgbClr val="FFFFFF"/>
+                </a:solidFill>
+                <a:latin typeface="Ubuntu"/>
+              </a:rPr>
+              <a:t> o Ubuntu Linux</a:t>
+            </a:r>
+            <a:r>
+              <a:rPr lang="pt-BR" sz="4200" b="1" i="0" u="none" dirty="0">
+                <a:solidFill>
+                  <a:srgbClr val="FFFFFF"/>
+                </a:solidFill>
+                <a:latin typeface="Ubuntu"/>
+              </a:rPr>
+              <a:t>_</a:t>
+            </a:r>
+            <a:endParaRPr sz="4200" b="1" i="0" u="none" dirty="0">
+              <a:solidFill>
+                <a:srgbClr val="FFFFFF"/>
+              </a:solidFill>
+              <a:latin typeface="Ubuntu"/>
+            </a:endParaRPr>
           </a:p>
         </p:txBody>
       </p:sp>
@@ -3255,7 +3281,7 @@
           <a:noFill/>
         </p:spPr>
         <p:txBody>
-          <a:bodyPr wrap="square" lIns="0" rIns="0" tIns="0" bIns="0" anchor="t">
+          <a:bodyPr wrap="square" lIns="0" tIns="0" rIns="0" bIns="0" anchor="t">
             <a:spAutoFit/>
           </a:bodyPr>
           <a:lstStyle/>
@@ -3266,7 +3292,7 @@
               </a:lnSpc>
             </a:pPr>
             <a:r>
-              <a:rPr b="0" sz="1650" i="0" u="none">
+              <a:rPr sz="1650" b="0" i="0" u="none">
                 <a:solidFill>
                   <a:srgbClr val="E0D0DC"/>
                 </a:solidFill>
@@ -3286,7 +3312,7 @@
 </file>
 
 <file path=ppt/slides/slide10.xml><?xml version="1.0" encoding="utf-8"?>
-<p:sld xmlns:a="http://schemas.openxmlformats.org/drawingml/2006/main" xmlns:p="http://schemas.openxmlformats.org/presentationml/2006/main" xmlns:r="http://schemas.openxmlformats.org/officeDocument/2006/relationships">
+<p:sld xmlns:a="http://schemas.openxmlformats.org/drawingml/2006/main" xmlns:r="http://schemas.openxmlformats.org/officeDocument/2006/relationships" xmlns:p="http://schemas.openxmlformats.org/presentationml/2006/main">
   <p:cSld>
     <p:bg>
       <p:bgPr>
@@ -3302,7 +3328,14 @@
         <p:cNvGrpSpPr/>
         <p:nvPr/>
       </p:nvGrpSpPr>
-      <p:grpSpPr/>
+      <p:grpSpPr>
+        <a:xfrm>
+          <a:off x="0" y="0"/>
+          <a:ext cx="0" cy="0"/>
+          <a:chOff x="0" y="0"/>
+          <a:chExt cx="0" cy="0"/>
+        </a:xfrm>
+      </p:grpSpPr>
       <p:sp>
         <p:nvSpPr>
           <p:cNvPr id="2" name="Rounded Rectangle 1"/>
@@ -3348,6 +3381,7 @@
           <a:lstStyle/>
           <a:p>
             <a:pPr algn="ctr"/>
+            <a:endParaRPr/>
           </a:p>
         </p:txBody>
       </p:sp>
@@ -3396,6 +3430,7 @@
           <a:lstStyle/>
           <a:p>
             <a:pPr algn="ctr"/>
+            <a:endParaRPr/>
           </a:p>
         </p:txBody>
       </p:sp>
@@ -3512,14 +3547,14 @@
           <a:noFill/>
         </p:spPr>
         <p:txBody>
-          <a:bodyPr wrap="none" lIns="0" rIns="0" tIns="0" bIns="0" anchor="t">
+          <a:bodyPr wrap="none" lIns="0" tIns="0" rIns="0" bIns="0" anchor="t">
             <a:spAutoFit/>
           </a:bodyPr>
           <a:lstStyle/>
           <a:p>
             <a:pPr algn="l"/>
             <a:r>
-              <a:rPr b="1" sz="1050" i="0" u="none">
+              <a:rPr sz="1050" b="1" i="0" u="none">
                 <a:solidFill>
                   <a:srgbClr val="E95420"/>
                 </a:solidFill>
@@ -3547,14 +3582,14 @@
           <a:noFill/>
         </p:spPr>
         <p:txBody>
-          <a:bodyPr wrap="none" lIns="0" rIns="0" tIns="0" bIns="0" anchor="t">
+          <a:bodyPr wrap="none" lIns="0" tIns="0" rIns="0" bIns="0" anchor="t">
             <a:spAutoFit/>
           </a:bodyPr>
           <a:lstStyle/>
           <a:p>
             <a:pPr algn="l"/>
             <a:r>
-              <a:rPr b="1" sz="2700" i="0" u="none">
+              <a:rPr sz="2700" b="1" i="0" u="none">
                 <a:solidFill>
                   <a:srgbClr val="0F172A"/>
                 </a:solidFill>
@@ -3582,14 +3617,14 @@
           <a:noFill/>
         </p:spPr>
         <p:txBody>
-          <a:bodyPr wrap="none" lIns="0" rIns="0" tIns="0" bIns="0" anchor="t">
+          <a:bodyPr wrap="none" lIns="0" tIns="0" rIns="0" bIns="0" anchor="t">
             <a:spAutoFit/>
           </a:bodyPr>
           <a:lstStyle/>
           <a:p>
             <a:pPr algn="l"/>
             <a:r>
-              <a:rPr b="1" sz="1500" i="0" u="none">
+              <a:rPr sz="1500" b="1" i="0" u="none">
                 <a:solidFill>
                   <a:srgbClr val="0F172A"/>
                 </a:solidFill>
@@ -3617,14 +3652,14 @@
           <a:noFill/>
         </p:spPr>
         <p:txBody>
-          <a:bodyPr wrap="square" lIns="0" rIns="0" tIns="0" bIns="0" anchor="t">
+          <a:bodyPr wrap="square" lIns="0" tIns="0" rIns="0" bIns="0" anchor="t">
             <a:spAutoFit/>
           </a:bodyPr>
           <a:lstStyle/>
           <a:p>
             <a:pPr algn="l"/>
             <a:r>
-              <a:rPr b="0" sz="1125" i="0" u="none">
+              <a:rPr sz="1125" b="0" i="0" u="none">
                 <a:solidFill>
                   <a:srgbClr val="475569"/>
                 </a:solidFill>
@@ -3652,14 +3687,14 @@
           <a:noFill/>
         </p:spPr>
         <p:txBody>
-          <a:bodyPr wrap="none" lIns="0" rIns="0" tIns="0" bIns="0" anchor="t">
+          <a:bodyPr wrap="none" lIns="0" tIns="0" rIns="0" bIns="0" anchor="t">
             <a:spAutoFit/>
           </a:bodyPr>
           <a:lstStyle/>
           <a:p>
             <a:pPr algn="l"/>
             <a:r>
-              <a:rPr b="1" sz="1500" i="0" u="none">
+              <a:rPr sz="1500" b="1" i="0" u="none">
                 <a:solidFill>
                   <a:srgbClr val="0F172A"/>
                 </a:solidFill>
@@ -3687,14 +3722,14 @@
           <a:noFill/>
         </p:spPr>
         <p:txBody>
-          <a:bodyPr wrap="square" lIns="0" rIns="0" tIns="0" bIns="0" anchor="t">
+          <a:bodyPr wrap="square" lIns="0" tIns="0" rIns="0" bIns="0" anchor="t">
             <a:spAutoFit/>
           </a:bodyPr>
           <a:lstStyle/>
           <a:p>
             <a:pPr algn="l"/>
             <a:r>
-              <a:rPr b="0" sz="1125" i="0" u="none">
+              <a:rPr sz="1125" b="0" i="0" u="none">
                 <a:solidFill>
                   <a:srgbClr val="475569"/>
                 </a:solidFill>
@@ -3714,7 +3749,7 @@
 </file>
 
 <file path=ppt/slides/slide11.xml><?xml version="1.0" encoding="utf-8"?>
-<p:sld xmlns:a="http://schemas.openxmlformats.org/drawingml/2006/main" xmlns:p="http://schemas.openxmlformats.org/presentationml/2006/main" xmlns:r="http://schemas.openxmlformats.org/officeDocument/2006/relationships">
+<p:sld xmlns:a="http://schemas.openxmlformats.org/drawingml/2006/main" xmlns:r="http://schemas.openxmlformats.org/officeDocument/2006/relationships" xmlns:p="http://schemas.openxmlformats.org/presentationml/2006/main">
   <p:cSld>
     <p:bg>
       <p:bgPr>
@@ -3730,7 +3765,14 @@
         <p:cNvGrpSpPr/>
         <p:nvPr/>
       </p:nvGrpSpPr>
-      <p:grpSpPr/>
+      <p:grpSpPr>
+        <a:xfrm>
+          <a:off x="0" y="0"/>
+          <a:ext cx="0" cy="0"/>
+          <a:chOff x="0" y="0"/>
+          <a:chExt cx="0" cy="0"/>
+        </a:xfrm>
+      </p:grpSpPr>
       <p:sp>
         <p:nvSpPr>
           <p:cNvPr id="2" name="Rounded Rectangle 1"/>
@@ -3776,6 +3818,7 @@
           <a:lstStyle/>
           <a:p>
             <a:pPr algn="ctr"/>
+            <a:endParaRPr/>
           </a:p>
         </p:txBody>
       </p:sp>
@@ -3824,6 +3867,7 @@
           <a:lstStyle/>
           <a:p>
             <a:pPr algn="ctr"/>
+            <a:endParaRPr/>
           </a:p>
         </p:txBody>
       </p:sp>
@@ -3872,6 +3916,7 @@
           <a:lstStyle/>
           <a:p>
             <a:pPr algn="ctr"/>
+            <a:endParaRPr/>
           </a:p>
         </p:txBody>
       </p:sp>
@@ -3920,6 +3965,7 @@
           <a:lstStyle/>
           <a:p>
             <a:pPr algn="ctr"/>
+            <a:endParaRPr/>
           </a:p>
         </p:txBody>
       </p:sp>
@@ -3940,14 +3986,14 @@
           <a:noFill/>
         </p:spPr>
         <p:txBody>
-          <a:bodyPr wrap="none" lIns="0" rIns="0" tIns="0" bIns="0" anchor="t">
+          <a:bodyPr wrap="none" lIns="0" tIns="0" rIns="0" bIns="0" anchor="t">
             <a:spAutoFit/>
           </a:bodyPr>
           <a:lstStyle/>
           <a:p>
             <a:pPr algn="l"/>
             <a:r>
-              <a:rPr b="1" sz="1050" i="0" u="none">
+              <a:rPr sz="1050" b="1" i="0" u="none">
                 <a:solidFill>
                   <a:srgbClr val="E95420"/>
                 </a:solidFill>
@@ -3975,14 +4021,14 @@
           <a:noFill/>
         </p:spPr>
         <p:txBody>
-          <a:bodyPr wrap="none" lIns="0" rIns="0" tIns="0" bIns="0" anchor="t">
+          <a:bodyPr wrap="none" lIns="0" tIns="0" rIns="0" bIns="0" anchor="t">
             <a:spAutoFit/>
           </a:bodyPr>
           <a:lstStyle/>
           <a:p>
             <a:pPr algn="l"/>
             <a:r>
-              <a:rPr b="1" sz="2700" i="0" u="none">
+              <a:rPr sz="2700" b="1" i="0" u="none">
                 <a:solidFill>
                   <a:srgbClr val="0F172A"/>
                 </a:solidFill>
@@ -4010,14 +4056,14 @@
           <a:noFill/>
         </p:spPr>
         <p:txBody>
-          <a:bodyPr wrap="none" lIns="0" rIns="0" tIns="0" bIns="0" anchor="t">
+          <a:bodyPr wrap="none" lIns="0" tIns="0" rIns="0" bIns="0" anchor="t">
             <a:spAutoFit/>
           </a:bodyPr>
           <a:lstStyle/>
           <a:p>
             <a:pPr algn="l"/>
             <a:r>
-              <a:rPr b="1" sz="1350" i="0" u="none">
+              <a:rPr sz="1350" b="1" i="0" u="none">
                 <a:solidFill>
                   <a:srgbClr val="0F172A"/>
                 </a:solidFill>
@@ -4045,14 +4091,14 @@
           <a:noFill/>
         </p:spPr>
         <p:txBody>
-          <a:bodyPr wrap="square" lIns="0" rIns="0" tIns="0" bIns="0" anchor="t">
+          <a:bodyPr wrap="square" lIns="0" tIns="0" rIns="0" bIns="0" anchor="t">
             <a:spAutoFit/>
           </a:bodyPr>
           <a:lstStyle/>
           <a:p>
             <a:pPr algn="l"/>
             <a:r>
-              <a:rPr b="0" sz="1125" i="0" u="none">
+              <a:rPr sz="1125" b="0" i="0" u="none">
                 <a:solidFill>
                   <a:srgbClr val="475569"/>
                 </a:solidFill>
@@ -4080,14 +4126,14 @@
           <a:noFill/>
         </p:spPr>
         <p:txBody>
-          <a:bodyPr wrap="none" lIns="0" rIns="0" tIns="0" bIns="0" anchor="t">
+          <a:bodyPr wrap="none" lIns="0" tIns="0" rIns="0" bIns="0" anchor="t">
             <a:spAutoFit/>
           </a:bodyPr>
           <a:lstStyle/>
           <a:p>
             <a:pPr algn="l"/>
             <a:r>
-              <a:rPr b="1" sz="1350" i="0" u="none">
+              <a:rPr sz="1350" b="1" i="0" u="none">
                 <a:solidFill>
                   <a:srgbClr val="0F172A"/>
                 </a:solidFill>
@@ -4115,14 +4161,14 @@
           <a:noFill/>
         </p:spPr>
         <p:txBody>
-          <a:bodyPr wrap="square" lIns="0" rIns="0" tIns="0" bIns="0" anchor="t">
+          <a:bodyPr wrap="square" lIns="0" tIns="0" rIns="0" bIns="0" anchor="t">
             <a:spAutoFit/>
           </a:bodyPr>
           <a:lstStyle/>
           <a:p>
             <a:pPr algn="l"/>
             <a:r>
-              <a:rPr b="0" sz="1125" i="0" u="none">
+              <a:rPr sz="1125" b="0" i="0" u="none">
                 <a:solidFill>
                   <a:srgbClr val="475569"/>
                 </a:solidFill>
@@ -4150,14 +4196,14 @@
           <a:noFill/>
         </p:spPr>
         <p:txBody>
-          <a:bodyPr wrap="none" lIns="0" rIns="0" tIns="0" bIns="0" anchor="t">
+          <a:bodyPr wrap="none" lIns="0" tIns="0" rIns="0" bIns="0" anchor="t">
             <a:spAutoFit/>
           </a:bodyPr>
           <a:lstStyle/>
           <a:p>
             <a:pPr algn="l"/>
             <a:r>
-              <a:rPr b="1" sz="1350" i="0" u="none">
+              <a:rPr sz="1350" b="1" i="0" u="none">
                 <a:solidFill>
                   <a:srgbClr val="0F172A"/>
                 </a:solidFill>
@@ -4185,14 +4231,14 @@
           <a:noFill/>
         </p:spPr>
         <p:txBody>
-          <a:bodyPr wrap="square" lIns="0" rIns="0" tIns="0" bIns="0" anchor="t">
+          <a:bodyPr wrap="square" lIns="0" tIns="0" rIns="0" bIns="0" anchor="t">
             <a:spAutoFit/>
           </a:bodyPr>
           <a:lstStyle/>
           <a:p>
             <a:pPr algn="l"/>
             <a:r>
-              <a:rPr b="0" sz="1125" i="0" u="none">
+              <a:rPr sz="1125" b="0" i="0" u="none">
                 <a:solidFill>
                   <a:srgbClr val="475569"/>
                 </a:solidFill>
@@ -4220,14 +4266,14 @@
           <a:noFill/>
         </p:spPr>
         <p:txBody>
-          <a:bodyPr wrap="none" lIns="0" rIns="0" tIns="0" bIns="0" anchor="t">
+          <a:bodyPr wrap="none" lIns="0" tIns="0" rIns="0" bIns="0" anchor="t">
             <a:spAutoFit/>
           </a:bodyPr>
           <a:lstStyle/>
           <a:p>
             <a:pPr algn="l"/>
             <a:r>
-              <a:rPr b="1" sz="1350" i="0" u="none">
+              <a:rPr sz="1350" b="1" i="0" u="none">
                 <a:solidFill>
                   <a:srgbClr val="0F172A"/>
                 </a:solidFill>
@@ -4255,14 +4301,14 @@
           <a:noFill/>
         </p:spPr>
         <p:txBody>
-          <a:bodyPr wrap="square" lIns="0" rIns="0" tIns="0" bIns="0" anchor="t">
+          <a:bodyPr wrap="square" lIns="0" tIns="0" rIns="0" bIns="0" anchor="t">
             <a:spAutoFit/>
           </a:bodyPr>
           <a:lstStyle/>
           <a:p>
             <a:pPr algn="l"/>
             <a:r>
-              <a:rPr b="0" sz="1125" i="0" u="none">
+              <a:rPr sz="1125" b="0" i="0" u="none">
                 <a:solidFill>
                   <a:srgbClr val="475569"/>
                 </a:solidFill>
@@ -4282,7 +4328,7 @@
 </file>
 
 <file path=ppt/slides/slide12.xml><?xml version="1.0" encoding="utf-8"?>
-<p:sld xmlns:a="http://schemas.openxmlformats.org/drawingml/2006/main" xmlns:p="http://schemas.openxmlformats.org/presentationml/2006/main" xmlns:r="http://schemas.openxmlformats.org/officeDocument/2006/relationships">
+<p:sld xmlns:a="http://schemas.openxmlformats.org/drawingml/2006/main" xmlns:r="http://schemas.openxmlformats.org/officeDocument/2006/relationships" xmlns:p="http://schemas.openxmlformats.org/presentationml/2006/main">
   <p:cSld>
     <p:bg>
       <p:bgPr>
@@ -4298,7 +4344,14 @@
         <p:cNvGrpSpPr/>
         <p:nvPr/>
       </p:nvGrpSpPr>
-      <p:grpSpPr/>
+      <p:grpSpPr>
+        <a:xfrm>
+          <a:off x="0" y="0"/>
+          <a:ext cx="0" cy="0"/>
+          <a:chOff x="0" y="0"/>
+          <a:chExt cx="0" cy="0"/>
+        </a:xfrm>
+      </p:grpSpPr>
       <p:sp>
         <p:nvSpPr>
           <p:cNvPr id="2" name="Rounded Rectangle 1"/>
@@ -4342,6 +4395,7 @@
           <a:lstStyle/>
           <a:p>
             <a:pPr algn="ctr"/>
+            <a:endParaRPr/>
           </a:p>
         </p:txBody>
       </p:sp>
@@ -4362,14 +4416,14 @@
           <a:noFill/>
         </p:spPr>
         <p:txBody>
-          <a:bodyPr wrap="none" lIns="0" rIns="0" tIns="0" bIns="0" anchor="t">
+          <a:bodyPr wrap="none" lIns="0" tIns="0" rIns="0" bIns="0" anchor="t">
             <a:spAutoFit/>
           </a:bodyPr>
           <a:lstStyle/>
           <a:p>
             <a:pPr algn="ctr"/>
             <a:r>
-              <a:rPr b="1" sz="1200" i="0" u="none">
+              <a:rPr sz="1200" b="1" i="0" u="none">
                 <a:solidFill>
                   <a:srgbClr val="E95420"/>
                 </a:solidFill>
@@ -4397,14 +4451,14 @@
           <a:noFill/>
         </p:spPr>
         <p:txBody>
-          <a:bodyPr wrap="none" lIns="0" rIns="0" tIns="0" bIns="0" anchor="t">
+          <a:bodyPr wrap="none" lIns="0" tIns="0" rIns="0" bIns="0" anchor="t">
             <a:spAutoFit/>
           </a:bodyPr>
           <a:lstStyle/>
           <a:p>
             <a:pPr algn="ctr"/>
             <a:r>
-              <a:rPr b="1" sz="3900" i="0" u="none">
+              <a:rPr sz="3900" b="1" i="0" u="none">
                 <a:solidFill>
                   <a:srgbClr val="FFFFFF"/>
                 </a:solidFill>
@@ -4432,14 +4486,14 @@
           <a:noFill/>
         </p:spPr>
         <p:txBody>
-          <a:bodyPr wrap="none" lIns="0" rIns="0" tIns="0" bIns="0" anchor="t">
+          <a:bodyPr wrap="none" lIns="0" tIns="0" rIns="0" bIns="0" anchor="t">
             <a:spAutoFit/>
           </a:bodyPr>
           <a:lstStyle/>
           <a:p>
             <a:pPr algn="ctr"/>
             <a:r>
-              <a:rPr b="0" sz="1500" i="0" u="none">
+              <a:rPr sz="1500" b="0" i="0" u="none">
                 <a:solidFill>
                   <a:srgbClr val="E0D0DC"/>
                 </a:solidFill>
@@ -4467,14 +4521,14 @@
           <a:noFill/>
         </p:spPr>
         <p:txBody>
-          <a:bodyPr wrap="square" lIns="0" rIns="0" tIns="0" bIns="0" anchor="t">
+          <a:bodyPr wrap="square" lIns="0" tIns="0" rIns="0" bIns="0" anchor="t">
             <a:spAutoFit/>
           </a:bodyPr>
           <a:lstStyle/>
           <a:p>
             <a:pPr algn="ctr"/>
             <a:r>
-              <a:rPr b="1" sz="1350" i="0" u="none">
+              <a:rPr sz="1350" b="1" i="0" u="none">
                 <a:solidFill>
                   <a:srgbClr val="FFFFFF"/>
                 </a:solidFill>
@@ -4494,7 +4548,7 @@
 </file>
 
 <file path=ppt/slides/slide2.xml><?xml version="1.0" encoding="utf-8"?>
-<p:sld xmlns:a="http://schemas.openxmlformats.org/drawingml/2006/main" xmlns:p="http://schemas.openxmlformats.org/presentationml/2006/main" xmlns:r="http://schemas.openxmlformats.org/officeDocument/2006/relationships">
+<p:sld xmlns:a="http://schemas.openxmlformats.org/drawingml/2006/main" xmlns:r="http://schemas.openxmlformats.org/officeDocument/2006/relationships" xmlns:p="http://schemas.openxmlformats.org/presentationml/2006/main">
   <p:cSld>
     <p:bg>
       <p:bgPr>
@@ -4510,7 +4564,14 @@
         <p:cNvGrpSpPr/>
         <p:nvPr/>
       </p:nvGrpSpPr>
-      <p:grpSpPr/>
+      <p:grpSpPr>
+        <a:xfrm>
+          <a:off x="0" y="0"/>
+          <a:ext cx="0" cy="0"/>
+          <a:chOff x="0" y="0"/>
+          <a:chExt cx="0" cy="0"/>
+        </a:xfrm>
+      </p:grpSpPr>
       <p:sp>
         <p:nvSpPr>
           <p:cNvPr id="2" name="Rounded Rectangle 1"/>
@@ -4554,6 +4615,7 @@
           <a:lstStyle/>
           <a:p>
             <a:pPr algn="ctr"/>
+            <a:endParaRPr/>
           </a:p>
         </p:txBody>
       </p:sp>
@@ -4600,6 +4662,7 @@
           <a:lstStyle/>
           <a:p>
             <a:pPr algn="ctr"/>
+            <a:endParaRPr/>
           </a:p>
         </p:txBody>
       </p:sp>
@@ -4646,6 +4709,7 @@
           <a:lstStyle/>
           <a:p>
             <a:pPr algn="ctr"/>
+            <a:endParaRPr/>
           </a:p>
         </p:txBody>
       </p:sp>
@@ -4666,14 +4730,14 @@
           <a:noFill/>
         </p:spPr>
         <p:txBody>
-          <a:bodyPr wrap="none" lIns="0" rIns="0" tIns="0" bIns="0" anchor="t">
+          <a:bodyPr wrap="none" lIns="0" tIns="0" rIns="0" bIns="0" anchor="t">
             <a:spAutoFit/>
           </a:bodyPr>
           <a:lstStyle/>
           <a:p>
             <a:pPr algn="l"/>
             <a:r>
-              <a:rPr b="1" sz="1050" i="0" u="none">
+              <a:rPr sz="1050" b="1" i="0" u="none">
                 <a:solidFill>
                   <a:srgbClr val="E95420"/>
                 </a:solidFill>
@@ -4701,14 +4765,14 @@
           <a:noFill/>
         </p:spPr>
         <p:txBody>
-          <a:bodyPr wrap="none" lIns="0" rIns="0" tIns="0" bIns="0" anchor="t">
+          <a:bodyPr wrap="none" lIns="0" tIns="0" rIns="0" bIns="0" anchor="t">
             <a:spAutoFit/>
           </a:bodyPr>
           <a:lstStyle/>
           <a:p>
             <a:pPr algn="l"/>
             <a:r>
-              <a:rPr b="1" sz="2700" i="0" u="none">
+              <a:rPr sz="2700" b="1" i="0" u="none">
                 <a:solidFill>
                   <a:srgbClr val="0F172A"/>
                 </a:solidFill>
@@ -4736,7 +4800,7 @@
           <a:noFill/>
         </p:spPr>
         <p:txBody>
-          <a:bodyPr wrap="none" lIns="0" rIns="0" tIns="0" bIns="0" anchor="t">
+          <a:bodyPr wrap="none" lIns="0" tIns="0" rIns="0" bIns="0" anchor="t">
             <a:spAutoFit/>
           </a:bodyPr>
           <a:lstStyle/>
@@ -4747,7 +4811,7 @@
               </a:lnSpc>
             </a:pPr>
             <a:r>
-              <a:rPr b="1" sz="4200" i="0" u="none">
+              <a:rPr sz="4200" b="1" i="0" u="none">
                 <a:solidFill>
                   <a:srgbClr val="E95420"/>
                 </a:solidFill>
@@ -4775,14 +4839,14 @@
           <a:noFill/>
         </p:spPr>
         <p:txBody>
-          <a:bodyPr wrap="none" lIns="0" rIns="0" tIns="0" bIns="0" anchor="t">
+          <a:bodyPr wrap="none" lIns="0" tIns="0" rIns="0" bIns="0" anchor="t">
             <a:spAutoFit/>
           </a:bodyPr>
           <a:lstStyle/>
           <a:p>
             <a:pPr algn="ctr"/>
             <a:r>
-              <a:rPr b="1" sz="1350" i="0" u="none">
+              <a:rPr sz="1350" b="1" i="0" u="none">
                 <a:solidFill>
                   <a:srgbClr val="0F172A"/>
                 </a:solidFill>
@@ -4810,14 +4874,14 @@
           <a:noFill/>
         </p:spPr>
         <p:txBody>
-          <a:bodyPr wrap="none" lIns="0" rIns="0" tIns="0" bIns="0" anchor="t">
+          <a:bodyPr wrap="none" lIns="0" tIns="0" rIns="0" bIns="0" anchor="t">
             <a:spAutoFit/>
           </a:bodyPr>
           <a:lstStyle/>
           <a:p>
             <a:pPr algn="ctr"/>
             <a:r>
-              <a:rPr b="0" sz="1050" i="0" u="none">
+              <a:rPr sz="1050" b="0" i="0" u="none">
                 <a:solidFill>
                   <a:srgbClr val="64748B"/>
                 </a:solidFill>
@@ -4845,7 +4909,7 @@
           <a:noFill/>
         </p:spPr>
         <p:txBody>
-          <a:bodyPr wrap="none" lIns="0" rIns="0" tIns="0" bIns="0" anchor="t">
+          <a:bodyPr wrap="none" lIns="0" tIns="0" rIns="0" bIns="0" anchor="t">
             <a:spAutoFit/>
           </a:bodyPr>
           <a:lstStyle/>
@@ -4856,7 +4920,7 @@
               </a:lnSpc>
             </a:pPr>
             <a:r>
-              <a:rPr b="1" sz="4200" i="0" u="none">
+              <a:rPr sz="4200" b="1" i="0" u="none">
                 <a:solidFill>
                   <a:srgbClr val="77216F"/>
                 </a:solidFill>
@@ -4884,14 +4948,14 @@
           <a:noFill/>
         </p:spPr>
         <p:txBody>
-          <a:bodyPr wrap="none" lIns="0" rIns="0" tIns="0" bIns="0" anchor="t">
+          <a:bodyPr wrap="none" lIns="0" tIns="0" rIns="0" bIns="0" anchor="t">
             <a:spAutoFit/>
           </a:bodyPr>
           <a:lstStyle/>
           <a:p>
             <a:pPr algn="ctr"/>
             <a:r>
-              <a:rPr b="1" sz="1350" i="0" u="none">
+              <a:rPr sz="1350" b="1" i="0" u="none">
                 <a:solidFill>
                   <a:srgbClr val="0F172A"/>
                 </a:solidFill>
@@ -4919,14 +4983,14 @@
           <a:noFill/>
         </p:spPr>
         <p:txBody>
-          <a:bodyPr wrap="none" lIns="0" rIns="0" tIns="0" bIns="0" anchor="t">
+          <a:bodyPr wrap="none" lIns="0" tIns="0" rIns="0" bIns="0" anchor="t">
             <a:spAutoFit/>
           </a:bodyPr>
           <a:lstStyle/>
           <a:p>
             <a:pPr algn="ctr"/>
             <a:r>
-              <a:rPr b="0" sz="1050" i="0" u="none">
+              <a:rPr sz="1050" b="0" i="0" u="none">
                 <a:solidFill>
                   <a:srgbClr val="64748B"/>
                 </a:solidFill>
@@ -4954,7 +5018,7 @@
           <a:noFill/>
         </p:spPr>
         <p:txBody>
-          <a:bodyPr wrap="none" lIns="0" rIns="0" tIns="0" bIns="0" anchor="t">
+          <a:bodyPr wrap="none" lIns="0" tIns="0" rIns="0" bIns="0" anchor="t">
             <a:spAutoFit/>
           </a:bodyPr>
           <a:lstStyle/>
@@ -4965,7 +5029,7 @@
               </a:lnSpc>
             </a:pPr>
             <a:r>
-              <a:rPr b="1" sz="4200" i="0" u="none">
+              <a:rPr sz="4200" b="1" i="0" u="none">
                 <a:solidFill>
                   <a:srgbClr val="E95420"/>
                 </a:solidFill>
@@ -4993,14 +5057,14 @@
           <a:noFill/>
         </p:spPr>
         <p:txBody>
-          <a:bodyPr wrap="none" lIns="0" rIns="0" tIns="0" bIns="0" anchor="t">
+          <a:bodyPr wrap="none" lIns="0" tIns="0" rIns="0" bIns="0" anchor="t">
             <a:spAutoFit/>
           </a:bodyPr>
           <a:lstStyle/>
           <a:p>
             <a:pPr algn="ctr"/>
             <a:r>
-              <a:rPr b="1" sz="1350" i="0" u="none">
+              <a:rPr sz="1350" b="1" i="0" u="none">
                 <a:solidFill>
                   <a:srgbClr val="0F172A"/>
                 </a:solidFill>
@@ -5028,14 +5092,14 @@
           <a:noFill/>
         </p:spPr>
         <p:txBody>
-          <a:bodyPr wrap="square" lIns="0" rIns="0" tIns="0" bIns="0" anchor="t">
+          <a:bodyPr wrap="square" lIns="0" tIns="0" rIns="0" bIns="0" anchor="t">
             <a:spAutoFit/>
           </a:bodyPr>
           <a:lstStyle/>
           <a:p>
             <a:pPr algn="ctr"/>
             <a:r>
-              <a:rPr b="0" sz="1050" i="0" u="none">
+              <a:rPr sz="1050" b="0" i="0" u="none">
                 <a:solidFill>
                   <a:srgbClr val="64748B"/>
                 </a:solidFill>
@@ -5055,7 +5119,7 @@
 </file>
 
 <file path=ppt/slides/slide3.xml><?xml version="1.0" encoding="utf-8"?>
-<p:sld xmlns:a="http://schemas.openxmlformats.org/drawingml/2006/main" xmlns:p="http://schemas.openxmlformats.org/presentationml/2006/main" xmlns:r="http://schemas.openxmlformats.org/officeDocument/2006/relationships">
+<p:sld xmlns:a="http://schemas.openxmlformats.org/drawingml/2006/main" xmlns:r="http://schemas.openxmlformats.org/officeDocument/2006/relationships" xmlns:p="http://schemas.openxmlformats.org/presentationml/2006/main">
   <p:cSld>
     <p:bg>
       <p:bgPr>
@@ -5071,7 +5135,14 @@
         <p:cNvGrpSpPr/>
         <p:nvPr/>
       </p:nvGrpSpPr>
-      <p:grpSpPr/>
+      <p:grpSpPr>
+        <a:xfrm>
+          <a:off x="0" y="0"/>
+          <a:ext cx="0" cy="0"/>
+          <a:chOff x="0" y="0"/>
+          <a:chExt cx="0" cy="0"/>
+        </a:xfrm>
+      </p:grpSpPr>
       <p:sp>
         <p:nvSpPr>
           <p:cNvPr id="2" name="Rounded Rectangle 1"/>
@@ -5115,6 +5186,7 @@
           <a:lstStyle/>
           <a:p>
             <a:pPr algn="ctr"/>
+            <a:endParaRPr/>
           </a:p>
         </p:txBody>
       </p:sp>
@@ -5161,6 +5233,7 @@
           <a:lstStyle/>
           <a:p>
             <a:pPr algn="ctr"/>
+            <a:endParaRPr/>
           </a:p>
         </p:txBody>
       </p:sp>
@@ -5207,6 +5280,7 @@
           <a:lstStyle/>
           <a:p>
             <a:pPr algn="ctr"/>
+            <a:endParaRPr/>
           </a:p>
         </p:txBody>
       </p:sp>
@@ -5371,14 +5445,14 @@
           <a:noFill/>
         </p:spPr>
         <p:txBody>
-          <a:bodyPr wrap="none" lIns="0" rIns="0" tIns="0" bIns="0" anchor="t">
+          <a:bodyPr wrap="none" lIns="0" tIns="0" rIns="0" bIns="0" anchor="t">
             <a:spAutoFit/>
           </a:bodyPr>
           <a:lstStyle/>
           <a:p>
             <a:pPr algn="l"/>
             <a:r>
-              <a:rPr b="1" sz="1050" i="0" u="none">
+              <a:rPr sz="1050" b="1" i="0" u="none">
                 <a:solidFill>
                   <a:srgbClr val="E95420"/>
                 </a:solidFill>
@@ -5406,14 +5480,14 @@
           <a:noFill/>
         </p:spPr>
         <p:txBody>
-          <a:bodyPr wrap="none" lIns="0" rIns="0" tIns="0" bIns="0" anchor="t">
+          <a:bodyPr wrap="none" lIns="0" tIns="0" rIns="0" bIns="0" anchor="t">
             <a:spAutoFit/>
           </a:bodyPr>
           <a:lstStyle/>
           <a:p>
             <a:pPr algn="l"/>
             <a:r>
-              <a:rPr b="1" sz="2700" i="0" u="none">
+              <a:rPr sz="2700" b="1" i="0" u="none">
                 <a:solidFill>
                   <a:srgbClr val="0F172A"/>
                 </a:solidFill>
@@ -5441,14 +5515,14 @@
           <a:noFill/>
         </p:spPr>
         <p:txBody>
-          <a:bodyPr wrap="none" lIns="0" rIns="0" tIns="0" bIns="0" anchor="t">
+          <a:bodyPr wrap="none" lIns="0" tIns="0" rIns="0" bIns="0" anchor="t">
             <a:spAutoFit/>
           </a:bodyPr>
           <a:lstStyle/>
           <a:p>
             <a:pPr algn="l"/>
             <a:r>
-              <a:rPr b="1" sz="1500" i="0" u="none">
+              <a:rPr sz="1500" b="1" i="0" u="none">
                 <a:solidFill>
                   <a:srgbClr val="0F172A"/>
                 </a:solidFill>
@@ -5476,14 +5550,14 @@
           <a:noFill/>
         </p:spPr>
         <p:txBody>
-          <a:bodyPr wrap="square" lIns="0" rIns="0" tIns="0" bIns="0" anchor="t">
+          <a:bodyPr wrap="square" lIns="0" tIns="0" rIns="0" bIns="0" anchor="t">
             <a:spAutoFit/>
           </a:bodyPr>
           <a:lstStyle/>
           <a:p>
             <a:pPr algn="l"/>
             <a:r>
-              <a:rPr b="0" sz="1200" i="0" u="none">
+              <a:rPr sz="1200" b="0" i="0" u="none">
                 <a:solidFill>
                   <a:srgbClr val="475569"/>
                 </a:solidFill>
@@ -5511,14 +5585,14 @@
           <a:noFill/>
         </p:spPr>
         <p:txBody>
-          <a:bodyPr wrap="none" lIns="0" rIns="0" tIns="0" bIns="0" anchor="t">
+          <a:bodyPr wrap="none" lIns="0" tIns="0" rIns="0" bIns="0" anchor="t">
             <a:spAutoFit/>
           </a:bodyPr>
           <a:lstStyle/>
           <a:p>
             <a:pPr algn="l"/>
             <a:r>
-              <a:rPr b="1" sz="1500" i="0" u="none">
+              <a:rPr sz="1500" b="1" i="0" u="none">
                 <a:solidFill>
                   <a:srgbClr val="0F172A"/>
                 </a:solidFill>
@@ -5546,14 +5620,14 @@
           <a:noFill/>
         </p:spPr>
         <p:txBody>
-          <a:bodyPr wrap="square" lIns="0" rIns="0" tIns="0" bIns="0" anchor="t">
+          <a:bodyPr wrap="square" lIns="0" tIns="0" rIns="0" bIns="0" anchor="t">
             <a:spAutoFit/>
           </a:bodyPr>
           <a:lstStyle/>
           <a:p>
             <a:pPr algn="l"/>
             <a:r>
-              <a:rPr b="0" sz="1200" i="0" u="none">
+              <a:rPr sz="1200" b="0" i="0" u="none">
                 <a:solidFill>
                   <a:srgbClr val="475569"/>
                 </a:solidFill>
@@ -5581,14 +5655,14 @@
           <a:noFill/>
         </p:spPr>
         <p:txBody>
-          <a:bodyPr wrap="none" lIns="0" rIns="0" tIns="0" bIns="0" anchor="t">
+          <a:bodyPr wrap="none" lIns="0" tIns="0" rIns="0" bIns="0" anchor="t">
             <a:spAutoFit/>
           </a:bodyPr>
           <a:lstStyle/>
           <a:p>
             <a:pPr algn="l"/>
             <a:r>
-              <a:rPr b="1" sz="1500" i="0" u="none">
+              <a:rPr sz="1500" b="1" i="0" u="none">
                 <a:solidFill>
                   <a:srgbClr val="0F172A"/>
                 </a:solidFill>
@@ -5616,14 +5690,14 @@
           <a:noFill/>
         </p:spPr>
         <p:txBody>
-          <a:bodyPr wrap="square" lIns="0" rIns="0" tIns="0" bIns="0" anchor="t">
+          <a:bodyPr wrap="square" lIns="0" tIns="0" rIns="0" bIns="0" anchor="t">
             <a:spAutoFit/>
           </a:bodyPr>
           <a:lstStyle/>
           <a:p>
             <a:pPr algn="l"/>
             <a:r>
-              <a:rPr b="0" sz="1200" i="0" u="none">
+              <a:rPr sz="1200" b="0" i="0" u="none">
                 <a:solidFill>
                   <a:srgbClr val="475569"/>
                 </a:solidFill>
@@ -5643,7 +5717,7 @@
 </file>
 
 <file path=ppt/slides/slide4.xml><?xml version="1.0" encoding="utf-8"?>
-<p:sld xmlns:a="http://schemas.openxmlformats.org/drawingml/2006/main" xmlns:p="http://schemas.openxmlformats.org/presentationml/2006/main" xmlns:r="http://schemas.openxmlformats.org/officeDocument/2006/relationships">
+<p:sld xmlns:a="http://schemas.openxmlformats.org/drawingml/2006/main" xmlns:r="http://schemas.openxmlformats.org/officeDocument/2006/relationships" xmlns:p="http://schemas.openxmlformats.org/presentationml/2006/main">
   <p:cSld>
     <p:bg>
       <p:bgPr>
@@ -5659,7 +5733,14 @@
         <p:cNvGrpSpPr/>
         <p:nvPr/>
       </p:nvGrpSpPr>
-      <p:grpSpPr/>
+      <p:grpSpPr>
+        <a:xfrm>
+          <a:off x="0" y="0"/>
+          <a:ext cx="0" cy="0"/>
+          <a:chOff x="0" y="0"/>
+          <a:chExt cx="0" cy="0"/>
+        </a:xfrm>
+      </p:grpSpPr>
       <p:sp>
         <p:nvSpPr>
           <p:cNvPr id="2" name="Rounded Rectangle 1"/>
@@ -5705,6 +5786,7 @@
           <a:lstStyle/>
           <a:p>
             <a:pPr algn="ctr"/>
+            <a:endParaRPr/>
           </a:p>
         </p:txBody>
       </p:sp>
@@ -5751,6 +5833,7 @@
           <a:lstStyle/>
           <a:p>
             <a:pPr algn="ctr"/>
+            <a:endParaRPr/>
           </a:p>
         </p:txBody>
       </p:sp>
@@ -5771,14 +5854,14 @@
           <a:noFill/>
         </p:spPr>
         <p:txBody>
-          <a:bodyPr wrap="none" lIns="0" rIns="0" tIns="0" bIns="0" anchor="t">
+          <a:bodyPr wrap="none" lIns="0" tIns="0" rIns="0" bIns="0" anchor="t">
             <a:spAutoFit/>
           </a:bodyPr>
           <a:lstStyle/>
           <a:p>
             <a:pPr algn="l"/>
             <a:r>
-              <a:rPr b="1" sz="1050" i="0" u="none">
+              <a:rPr sz="1050" b="1" i="0" u="none">
                 <a:solidFill>
                   <a:srgbClr val="E95420"/>
                 </a:solidFill>
@@ -5806,14 +5889,14 @@
           <a:noFill/>
         </p:spPr>
         <p:txBody>
-          <a:bodyPr wrap="none" lIns="0" rIns="0" tIns="0" bIns="0" anchor="t">
+          <a:bodyPr wrap="none" lIns="0" tIns="0" rIns="0" bIns="0" anchor="t">
             <a:spAutoFit/>
           </a:bodyPr>
           <a:lstStyle/>
           <a:p>
             <a:pPr algn="l"/>
             <a:r>
-              <a:rPr b="1" sz="2700" i="0" u="none">
+              <a:rPr sz="2700" b="1" i="0" u="none">
                 <a:solidFill>
                   <a:srgbClr val="0F172A"/>
                 </a:solidFill>
@@ -5841,14 +5924,14 @@
           <a:noFill/>
         </p:spPr>
         <p:txBody>
-          <a:bodyPr wrap="none" lIns="0" rIns="0" tIns="0" bIns="0" anchor="t">
+          <a:bodyPr wrap="none" lIns="0" tIns="0" rIns="0" bIns="0" anchor="t">
             <a:spAutoFit/>
           </a:bodyPr>
           <a:lstStyle/>
           <a:p>
             <a:pPr algn="l"/>
             <a:r>
-              <a:rPr b="1" sz="1500" i="0" u="none">
+              <a:rPr sz="1500" b="1" i="0" u="none">
                 <a:solidFill>
                   <a:srgbClr val="64748B"/>
                 </a:solidFill>
@@ -5876,14 +5959,14 @@
           <a:noFill/>
         </p:spPr>
         <p:txBody>
-          <a:bodyPr wrap="none" lIns="0" rIns="0" tIns="0" bIns="0" anchor="t">
+          <a:bodyPr wrap="none" lIns="0" tIns="0" rIns="0" bIns="0" anchor="t">
             <a:spAutoFit/>
           </a:bodyPr>
           <a:lstStyle/>
           <a:p>
             <a:pPr algn="l"/>
             <a:r>
-              <a:rPr b="1" sz="1500" i="0" u="none">
+              <a:rPr sz="1500" b="1" i="0" u="none">
                 <a:solidFill>
                   <a:srgbClr val="FFFFFF"/>
                 </a:solidFill>
@@ -5911,14 +5994,14 @@
           <a:noFill/>
         </p:spPr>
         <p:txBody>
-          <a:bodyPr wrap="square" lIns="0" rIns="0" tIns="0" bIns="0" anchor="t">
+          <a:bodyPr wrap="square" lIns="0" tIns="0" rIns="0" bIns="0" anchor="t">
             <a:spAutoFit/>
           </a:bodyPr>
           <a:lstStyle/>
           <a:p>
             <a:pPr algn="l"/>
             <a:r>
-              <a:rPr b="1" sz="1200" i="0" u="none">
+              <a:rPr sz="1200" b="1" i="0" u="none">
                 <a:solidFill>
                   <a:srgbClr val="475569"/>
                 </a:solidFill>
@@ -5927,7 +6010,7 @@
               <a:t>Atualizações Inesperadas:</a:t>
             </a:r>
             <a:r>
-              <a:rPr b="0" sz="1200" i="0" u="none">
+              <a:rPr sz="1200" b="0" i="0" u="none">
                 <a:solidFill>
                   <a:srgbClr val="475569"/>
                 </a:solidFill>
@@ -5955,14 +6038,14 @@
           <a:noFill/>
         </p:spPr>
         <p:txBody>
-          <a:bodyPr wrap="square" lIns="0" rIns="0" tIns="0" bIns="0" anchor="t">
+          <a:bodyPr wrap="square" lIns="0" tIns="0" rIns="0" bIns="0" anchor="t">
             <a:spAutoFit/>
           </a:bodyPr>
           <a:lstStyle/>
           <a:p>
             <a:pPr algn="l"/>
             <a:r>
-              <a:rPr b="1" sz="1200" i="0" u="none">
+              <a:rPr sz="1200" b="1" i="0" u="none">
                 <a:solidFill>
                   <a:srgbClr val="475569"/>
                 </a:solidFill>
@@ -5971,7 +6054,7 @@
               <a:t>Lentidão Progressiva:</a:t>
             </a:r>
             <a:r>
-              <a:rPr b="0" sz="1200" i="0" u="none">
+              <a:rPr sz="1200" b="0" i="0" u="none">
                 <a:solidFill>
                   <a:srgbClr val="475569"/>
                 </a:solidFill>
@@ -5999,14 +6082,14 @@
           <a:noFill/>
         </p:spPr>
         <p:txBody>
-          <a:bodyPr wrap="square" lIns="0" rIns="0" tIns="0" bIns="0" anchor="t">
+          <a:bodyPr wrap="square" lIns="0" tIns="0" rIns="0" bIns="0" anchor="t">
             <a:spAutoFit/>
           </a:bodyPr>
           <a:lstStyle/>
           <a:p>
             <a:pPr algn="l"/>
             <a:r>
-              <a:rPr b="1" sz="1200" i="0" u="none">
+              <a:rPr sz="1200" b="1" i="0" u="none">
                 <a:solidFill>
                   <a:srgbClr val="475569"/>
                 </a:solidFill>
@@ -6015,7 +6098,7 @@
               <a:t>Preocupação com Antivírus:</a:t>
             </a:r>
             <a:r>
-              <a:rPr b="0" sz="1200" i="0" u="none">
+              <a:rPr sz="1200" b="0" i="0" u="none">
                 <a:solidFill>
                   <a:srgbClr val="475569"/>
                 </a:solidFill>
@@ -6043,14 +6126,14 @@
           <a:noFill/>
         </p:spPr>
         <p:txBody>
-          <a:bodyPr wrap="square" lIns="0" rIns="0" tIns="0" bIns="0" anchor="t">
+          <a:bodyPr wrap="square" lIns="0" tIns="0" rIns="0" bIns="0" anchor="t">
             <a:spAutoFit/>
           </a:bodyPr>
           <a:lstStyle/>
           <a:p>
             <a:pPr algn="l"/>
             <a:r>
-              <a:rPr b="1" sz="1200" i="0" u="none">
+              <a:rPr sz="1200" b="1" i="0" u="none">
                 <a:solidFill>
                   <a:srgbClr val="F1F5F9"/>
                 </a:solidFill>
@@ -6059,7 +6142,7 @@
               <a:t>Você no Controle:</a:t>
             </a:r>
             <a:r>
-              <a:rPr b="0" sz="1200" i="0" u="none">
+              <a:rPr sz="1200" b="0" i="0" u="none">
                 <a:solidFill>
                   <a:srgbClr val="F1F5F9"/>
                 </a:solidFill>
@@ -6087,14 +6170,14 @@
           <a:noFill/>
         </p:spPr>
         <p:txBody>
-          <a:bodyPr wrap="none" lIns="0" rIns="0" tIns="0" bIns="0" anchor="t">
+          <a:bodyPr wrap="none" lIns="0" tIns="0" rIns="0" bIns="0" anchor="t">
             <a:spAutoFit/>
           </a:bodyPr>
           <a:lstStyle/>
           <a:p>
             <a:pPr algn="l"/>
             <a:r>
-              <a:rPr b="1" sz="1200" i="0" u="none">
+              <a:rPr sz="1200" b="1" i="0" u="none">
                 <a:solidFill>
                   <a:srgbClr val="F1F5F9"/>
                 </a:solidFill>
@@ -6103,7 +6186,7 @@
               <a:t>Desempenho Constante:</a:t>
             </a:r>
             <a:r>
-              <a:rPr b="0" sz="1200" i="0" u="none">
+              <a:rPr sz="1200" b="0" i="0" u="none">
                 <a:solidFill>
                   <a:srgbClr val="F1F5F9"/>
                 </a:solidFill>
@@ -6131,14 +6214,14 @@
           <a:noFill/>
         </p:spPr>
         <p:txBody>
-          <a:bodyPr wrap="none" lIns="0" rIns="0" tIns="0" bIns="0" anchor="t">
+          <a:bodyPr wrap="none" lIns="0" tIns="0" rIns="0" bIns="0" anchor="t">
             <a:spAutoFit/>
           </a:bodyPr>
           <a:lstStyle/>
           <a:p>
             <a:pPr algn="l"/>
             <a:r>
-              <a:rPr b="1" sz="1200" i="0" u="none">
+              <a:rPr sz="1200" b="1" i="0" u="none">
                 <a:solidFill>
                   <a:srgbClr val="F1F5F9"/>
                 </a:solidFill>
@@ -6147,7 +6230,7 @@
               <a:t>Tranquilidade Nativa:</a:t>
             </a:r>
             <a:r>
-              <a:rPr b="0" sz="1200" i="0" u="none">
+              <a:rPr sz="1200" b="0" i="0" u="none">
                 <a:solidFill>
                   <a:srgbClr val="F1F5F9"/>
                 </a:solidFill>
@@ -6167,7 +6250,7 @@
 </file>
 
 <file path=ppt/slides/slide5.xml><?xml version="1.0" encoding="utf-8"?>
-<p:sld xmlns:a="http://schemas.openxmlformats.org/drawingml/2006/main" xmlns:p="http://schemas.openxmlformats.org/presentationml/2006/main" xmlns:r="http://schemas.openxmlformats.org/officeDocument/2006/relationships">
+<p:sld xmlns:a="http://schemas.openxmlformats.org/drawingml/2006/main" xmlns:r="http://schemas.openxmlformats.org/officeDocument/2006/relationships" xmlns:p="http://schemas.openxmlformats.org/presentationml/2006/main">
   <p:cSld>
     <p:bg>
       <p:bgPr>
@@ -6183,7 +6266,14 @@
         <p:cNvGrpSpPr/>
         <p:nvPr/>
       </p:nvGrpSpPr>
-      <p:grpSpPr/>
+      <p:grpSpPr>
+        <a:xfrm>
+          <a:off x="0" y="0"/>
+          <a:ext cx="0" cy="0"/>
+          <a:chOff x="0" y="0"/>
+          <a:chExt cx="0" cy="0"/>
+        </a:xfrm>
+      </p:grpSpPr>
       <p:sp>
         <p:nvSpPr>
           <p:cNvPr id="2" name="Rounded Rectangle 1"/>
@@ -6229,6 +6319,7 @@
           <a:lstStyle/>
           <a:p>
             <a:pPr algn="ctr"/>
+            <a:endParaRPr/>
           </a:p>
         </p:txBody>
       </p:sp>
@@ -6277,6 +6368,7 @@
           <a:lstStyle/>
           <a:p>
             <a:pPr algn="ctr"/>
+            <a:endParaRPr/>
           </a:p>
         </p:txBody>
       </p:sp>
@@ -6325,6 +6417,7 @@
           <a:lstStyle/>
           <a:p>
             <a:pPr algn="ctr"/>
+            <a:endParaRPr/>
           </a:p>
         </p:txBody>
       </p:sp>
@@ -6489,14 +6582,14 @@
           <a:noFill/>
         </p:spPr>
         <p:txBody>
-          <a:bodyPr wrap="none" lIns="0" rIns="0" tIns="0" bIns="0" anchor="t">
+          <a:bodyPr wrap="none" lIns="0" tIns="0" rIns="0" bIns="0" anchor="t">
             <a:spAutoFit/>
           </a:bodyPr>
           <a:lstStyle/>
           <a:p>
             <a:pPr algn="l"/>
             <a:r>
-              <a:rPr b="1" sz="1050" i="0" u="none">
+              <a:rPr sz="1050" b="1" i="0" u="none">
                 <a:solidFill>
                   <a:srgbClr val="E95420"/>
                 </a:solidFill>
@@ -6524,14 +6617,14 @@
           <a:noFill/>
         </p:spPr>
         <p:txBody>
-          <a:bodyPr wrap="none" lIns="0" rIns="0" tIns="0" bIns="0" anchor="t">
+          <a:bodyPr wrap="none" lIns="0" tIns="0" rIns="0" bIns="0" anchor="t">
             <a:spAutoFit/>
           </a:bodyPr>
           <a:lstStyle/>
           <a:p>
             <a:pPr algn="l"/>
             <a:r>
-              <a:rPr b="1" sz="2700" i="0" u="none">
+              <a:rPr sz="2700" b="1" i="0" u="none">
                 <a:solidFill>
                   <a:srgbClr val="0F172A"/>
                 </a:solidFill>
@@ -6559,14 +6652,14 @@
           <a:noFill/>
         </p:spPr>
         <p:txBody>
-          <a:bodyPr wrap="none" lIns="0" rIns="0" tIns="0" bIns="0" anchor="t">
+          <a:bodyPr wrap="none" lIns="0" tIns="0" rIns="0" bIns="0" anchor="t">
             <a:spAutoFit/>
           </a:bodyPr>
           <a:lstStyle/>
           <a:p>
             <a:pPr algn="l"/>
             <a:r>
-              <a:rPr b="1" sz="1350" i="0" u="none">
+              <a:rPr sz="1350" b="1" i="0" u="none">
                 <a:solidFill>
                   <a:srgbClr val="0F172A"/>
                 </a:solidFill>
@@ -6594,14 +6687,14 @@
           <a:noFill/>
         </p:spPr>
         <p:txBody>
-          <a:bodyPr wrap="square" lIns="0" rIns="0" tIns="0" bIns="0" anchor="t">
+          <a:bodyPr wrap="square" lIns="0" tIns="0" rIns="0" bIns="0" anchor="t">
             <a:spAutoFit/>
           </a:bodyPr>
           <a:lstStyle/>
           <a:p>
             <a:pPr algn="l"/>
             <a:r>
-              <a:rPr b="0" sz="1125" i="0" u="none">
+              <a:rPr sz="1125" b="0" i="0" u="none">
                 <a:solidFill>
                   <a:srgbClr val="475569"/>
                 </a:solidFill>
@@ -6629,14 +6722,14 @@
           <a:noFill/>
         </p:spPr>
         <p:txBody>
-          <a:bodyPr wrap="none" lIns="0" rIns="0" tIns="0" bIns="0" anchor="t">
+          <a:bodyPr wrap="none" lIns="0" tIns="0" rIns="0" bIns="0" anchor="t">
             <a:spAutoFit/>
           </a:bodyPr>
           <a:lstStyle/>
           <a:p>
             <a:pPr algn="l"/>
             <a:r>
-              <a:rPr b="1" sz="1350" i="0" u="none">
+              <a:rPr sz="1350" b="1" i="0" u="none">
                 <a:solidFill>
                   <a:srgbClr val="0F172A"/>
                 </a:solidFill>
@@ -6664,14 +6757,14 @@
           <a:noFill/>
         </p:spPr>
         <p:txBody>
-          <a:bodyPr wrap="square" lIns="0" rIns="0" tIns="0" bIns="0" anchor="t">
+          <a:bodyPr wrap="square" lIns="0" tIns="0" rIns="0" bIns="0" anchor="t">
             <a:spAutoFit/>
           </a:bodyPr>
           <a:lstStyle/>
           <a:p>
             <a:pPr algn="l"/>
             <a:r>
-              <a:rPr b="0" sz="1125" i="0" u="none">
+              <a:rPr sz="1125" b="0" i="0" u="none">
                 <a:solidFill>
                   <a:srgbClr val="475569"/>
                 </a:solidFill>
@@ -6699,14 +6792,14 @@
           <a:noFill/>
         </p:spPr>
         <p:txBody>
-          <a:bodyPr wrap="none" lIns="0" rIns="0" tIns="0" bIns="0" anchor="t">
+          <a:bodyPr wrap="none" lIns="0" tIns="0" rIns="0" bIns="0" anchor="t">
             <a:spAutoFit/>
           </a:bodyPr>
           <a:lstStyle/>
           <a:p>
             <a:pPr algn="l"/>
             <a:r>
-              <a:rPr b="1" sz="1350" i="0" u="none">
+              <a:rPr sz="1350" b="1" i="0" u="none">
                 <a:solidFill>
                   <a:srgbClr val="0F172A"/>
                 </a:solidFill>
@@ -6734,14 +6827,14 @@
           <a:noFill/>
         </p:spPr>
         <p:txBody>
-          <a:bodyPr wrap="square" lIns="0" rIns="0" tIns="0" bIns="0" anchor="t">
+          <a:bodyPr wrap="square" lIns="0" tIns="0" rIns="0" bIns="0" anchor="t">
             <a:spAutoFit/>
           </a:bodyPr>
           <a:lstStyle/>
           <a:p>
             <a:pPr algn="l"/>
             <a:r>
-              <a:rPr b="0" sz="1125" i="0" u="none">
+              <a:rPr sz="1125" b="0" i="0" u="none">
                 <a:solidFill>
                   <a:srgbClr val="475569"/>
                 </a:solidFill>
@@ -6761,7 +6854,7 @@
 </file>
 
 <file path=ppt/slides/slide6.xml><?xml version="1.0" encoding="utf-8"?>
-<p:sld xmlns:a="http://schemas.openxmlformats.org/drawingml/2006/main" xmlns:p="http://schemas.openxmlformats.org/presentationml/2006/main" xmlns:r="http://schemas.openxmlformats.org/officeDocument/2006/relationships">
+<p:sld xmlns:a="http://schemas.openxmlformats.org/drawingml/2006/main" xmlns:r="http://schemas.openxmlformats.org/officeDocument/2006/relationships" xmlns:p="http://schemas.openxmlformats.org/presentationml/2006/main">
   <p:cSld>
     <p:bg>
       <p:bgPr>
@@ -6777,7 +6870,14 @@
         <p:cNvGrpSpPr/>
         <p:nvPr/>
       </p:nvGrpSpPr>
-      <p:grpSpPr/>
+      <p:grpSpPr>
+        <a:xfrm>
+          <a:off x="0" y="0"/>
+          <a:ext cx="0" cy="0"/>
+          <a:chOff x="0" y="0"/>
+          <a:chExt cx="0" cy="0"/>
+        </a:xfrm>
+      </p:grpSpPr>
       <p:sp>
         <p:nvSpPr>
           <p:cNvPr id="2" name="Rounded Rectangle 1"/>
@@ -6821,6 +6921,7 @@
           <a:lstStyle/>
           <a:p>
             <a:pPr algn="ctr"/>
+            <a:endParaRPr/>
           </a:p>
         </p:txBody>
       </p:sp>
@@ -6867,6 +6968,7 @@
           <a:lstStyle/>
           <a:p>
             <a:pPr algn="ctr"/>
+            <a:endParaRPr/>
           </a:p>
         </p:txBody>
       </p:sp>
@@ -6913,6 +7015,7 @@
           <a:lstStyle/>
           <a:p>
             <a:pPr algn="ctr"/>
+            <a:endParaRPr/>
           </a:p>
         </p:txBody>
       </p:sp>
@@ -6957,6 +7060,7 @@
           <a:lstStyle/>
           <a:p>
             <a:pPr algn="ctr"/>
+            <a:endParaRPr/>
           </a:p>
         </p:txBody>
       </p:sp>
@@ -7001,6 +7105,7 @@
           <a:lstStyle/>
           <a:p>
             <a:pPr algn="ctr"/>
+            <a:endParaRPr/>
           </a:p>
         </p:txBody>
       </p:sp>
@@ -7045,6 +7150,7 @@
           <a:lstStyle/>
           <a:p>
             <a:pPr algn="ctr"/>
+            <a:endParaRPr/>
           </a:p>
         </p:txBody>
       </p:sp>
@@ -7065,14 +7171,14 @@
           <a:noFill/>
         </p:spPr>
         <p:txBody>
-          <a:bodyPr wrap="none" lIns="0" rIns="0" tIns="0" bIns="0" anchor="t">
+          <a:bodyPr wrap="none" lIns="0" tIns="0" rIns="0" bIns="0" anchor="t">
             <a:spAutoFit/>
           </a:bodyPr>
           <a:lstStyle/>
           <a:p>
             <a:pPr algn="l"/>
             <a:r>
-              <a:rPr b="1" sz="1050" i="0" u="none">
+              <a:rPr sz="1050" b="1" i="0" u="none">
                 <a:solidFill>
                   <a:srgbClr val="E95420"/>
                 </a:solidFill>
@@ -7100,14 +7206,14 @@
           <a:noFill/>
         </p:spPr>
         <p:txBody>
-          <a:bodyPr wrap="none" lIns="0" rIns="0" tIns="0" bIns="0" anchor="t">
+          <a:bodyPr wrap="none" lIns="0" tIns="0" rIns="0" bIns="0" anchor="t">
             <a:spAutoFit/>
           </a:bodyPr>
           <a:lstStyle/>
           <a:p>
             <a:pPr algn="l"/>
             <a:r>
-              <a:rPr b="1" sz="2700" i="0" u="none">
+              <a:rPr sz="2700" b="1" i="0" u="none">
                 <a:solidFill>
                   <a:srgbClr val="0F172A"/>
                 </a:solidFill>
@@ -7135,14 +7241,14 @@
           <a:noFill/>
         </p:spPr>
         <p:txBody>
-          <a:bodyPr wrap="none" lIns="0" rIns="0" tIns="0" bIns="0" anchor="t">
+          <a:bodyPr wrap="none" lIns="0" tIns="0" rIns="0" bIns="0" anchor="t">
             <a:spAutoFit/>
           </a:bodyPr>
           <a:lstStyle/>
           <a:p>
             <a:pPr algn="l"/>
             <a:r>
-              <a:rPr b="1" sz="1050" i="0" u="none">
+              <a:rPr sz="1050" b="1" i="0" u="none">
                 <a:solidFill>
                   <a:srgbClr val="E95420"/>
                 </a:solidFill>
@@ -7170,14 +7276,14 @@
           <a:noFill/>
         </p:spPr>
         <p:txBody>
-          <a:bodyPr wrap="none" lIns="0" rIns="0" tIns="0" bIns="0" anchor="t">
+          <a:bodyPr wrap="none" lIns="0" tIns="0" rIns="0" bIns="0" anchor="t">
             <a:spAutoFit/>
           </a:bodyPr>
           <a:lstStyle/>
           <a:p>
             <a:pPr algn="l"/>
             <a:r>
-              <a:rPr b="1" sz="1500" i="0" u="none">
+              <a:rPr sz="1500" b="1" i="0" u="none">
                 <a:solidFill>
                   <a:srgbClr val="0F172A"/>
                 </a:solidFill>
@@ -7205,14 +7311,14 @@
           <a:noFill/>
         </p:spPr>
         <p:txBody>
-          <a:bodyPr wrap="square" lIns="0" rIns="0" tIns="0" bIns="0" anchor="t">
+          <a:bodyPr wrap="square" lIns="0" tIns="0" rIns="0" bIns="0" anchor="t">
             <a:spAutoFit/>
           </a:bodyPr>
           <a:lstStyle/>
           <a:p>
             <a:pPr algn="l"/>
             <a:r>
-              <a:rPr b="0" sz="1125" i="0" u="none">
+              <a:rPr sz="1125" b="0" i="0" u="none">
                 <a:solidFill>
                   <a:srgbClr val="475569"/>
                 </a:solidFill>
@@ -7240,14 +7346,14 @@
           <a:noFill/>
         </p:spPr>
         <p:txBody>
-          <a:bodyPr wrap="none" lIns="0" rIns="0" tIns="0" bIns="0" anchor="t">
+          <a:bodyPr wrap="none" lIns="0" tIns="0" rIns="0" bIns="0" anchor="t">
             <a:spAutoFit/>
           </a:bodyPr>
           <a:lstStyle/>
           <a:p>
             <a:pPr algn="l"/>
             <a:r>
-              <a:rPr b="1" sz="1050" i="0" u="none">
+              <a:rPr sz="1050" b="1" i="0" u="none">
                 <a:solidFill>
                   <a:srgbClr val="77216F"/>
                 </a:solidFill>
@@ -7275,14 +7381,14 @@
           <a:noFill/>
         </p:spPr>
         <p:txBody>
-          <a:bodyPr wrap="none" lIns="0" rIns="0" tIns="0" bIns="0" anchor="t">
+          <a:bodyPr wrap="none" lIns="0" tIns="0" rIns="0" bIns="0" anchor="t">
             <a:spAutoFit/>
           </a:bodyPr>
           <a:lstStyle/>
           <a:p>
             <a:pPr algn="l"/>
             <a:r>
-              <a:rPr b="1" sz="1500" i="0" u="none">
+              <a:rPr sz="1500" b="1" i="0" u="none">
                 <a:solidFill>
                   <a:srgbClr val="0F172A"/>
                 </a:solidFill>
@@ -7310,14 +7416,14 @@
           <a:noFill/>
         </p:spPr>
         <p:txBody>
-          <a:bodyPr wrap="square" lIns="0" rIns="0" tIns="0" bIns="0" anchor="t">
+          <a:bodyPr wrap="square" lIns="0" tIns="0" rIns="0" bIns="0" anchor="t">
             <a:spAutoFit/>
           </a:bodyPr>
           <a:lstStyle/>
           <a:p>
             <a:pPr algn="l"/>
             <a:r>
-              <a:rPr b="0" sz="1125" i="0" u="none">
+              <a:rPr sz="1125" b="0" i="0" u="none">
                 <a:solidFill>
                   <a:srgbClr val="475569"/>
                 </a:solidFill>
@@ -7345,14 +7451,14 @@
           <a:noFill/>
         </p:spPr>
         <p:txBody>
-          <a:bodyPr wrap="none" lIns="0" rIns="0" tIns="0" bIns="0" anchor="t">
+          <a:bodyPr wrap="none" lIns="0" tIns="0" rIns="0" bIns="0" anchor="t">
             <a:spAutoFit/>
           </a:bodyPr>
           <a:lstStyle/>
           <a:p>
             <a:pPr algn="l"/>
             <a:r>
-              <a:rPr b="1" sz="1050" i="0" u="none">
+              <a:rPr sz="1050" b="1" i="0" u="none">
                 <a:solidFill>
                   <a:srgbClr val="E95420"/>
                 </a:solidFill>
@@ -7380,14 +7486,14 @@
           <a:noFill/>
         </p:spPr>
         <p:txBody>
-          <a:bodyPr wrap="none" lIns="0" rIns="0" tIns="0" bIns="0" anchor="t">
+          <a:bodyPr wrap="none" lIns="0" tIns="0" rIns="0" bIns="0" anchor="t">
             <a:spAutoFit/>
           </a:bodyPr>
           <a:lstStyle/>
           <a:p>
             <a:pPr algn="l"/>
             <a:r>
-              <a:rPr b="1" sz="1350" i="0" u="none">
+              <a:rPr sz="1350" b="1" i="0" u="none">
                 <a:solidFill>
                   <a:srgbClr val="0F172A"/>
                 </a:solidFill>
@@ -7415,14 +7521,14 @@
           <a:noFill/>
         </p:spPr>
         <p:txBody>
-          <a:bodyPr wrap="square" lIns="0" rIns="0" tIns="0" bIns="0" anchor="t">
+          <a:bodyPr wrap="square" lIns="0" tIns="0" rIns="0" bIns="0" anchor="t">
             <a:spAutoFit/>
           </a:bodyPr>
           <a:lstStyle/>
           <a:p>
             <a:pPr algn="l"/>
             <a:r>
-              <a:rPr b="0" sz="1125" i="0" u="none">
+              <a:rPr sz="1125" b="0" i="0" u="none">
                 <a:solidFill>
                   <a:srgbClr val="475569"/>
                 </a:solidFill>
@@ -7442,7 +7548,7 @@
 </file>
 
 <file path=ppt/slides/slide7.xml><?xml version="1.0" encoding="utf-8"?>
-<p:sld xmlns:a="http://schemas.openxmlformats.org/drawingml/2006/main" xmlns:p="http://schemas.openxmlformats.org/presentationml/2006/main" xmlns:r="http://schemas.openxmlformats.org/officeDocument/2006/relationships">
+<p:sld xmlns:a="http://schemas.openxmlformats.org/drawingml/2006/main" xmlns:r="http://schemas.openxmlformats.org/officeDocument/2006/relationships" xmlns:p="http://schemas.openxmlformats.org/presentationml/2006/main">
   <p:cSld>
     <p:bg>
       <p:bgPr>
@@ -7458,7 +7564,14 @@
         <p:cNvGrpSpPr/>
         <p:nvPr/>
       </p:nvGrpSpPr>
-      <p:grpSpPr/>
+      <p:grpSpPr>
+        <a:xfrm>
+          <a:off x="0" y="0"/>
+          <a:ext cx="0" cy="0"/>
+          <a:chOff x="0" y="0"/>
+          <a:chExt cx="0" cy="0"/>
+        </a:xfrm>
+      </p:grpSpPr>
       <p:sp>
         <p:nvSpPr>
           <p:cNvPr id="2" name="Rounded Rectangle 1"/>
@@ -7504,6 +7617,7 @@
           <a:lstStyle/>
           <a:p>
             <a:pPr algn="ctr"/>
+            <a:endParaRPr/>
           </a:p>
         </p:txBody>
       </p:sp>
@@ -7552,6 +7666,7 @@
           <a:lstStyle/>
           <a:p>
             <a:pPr algn="ctr"/>
+            <a:endParaRPr/>
           </a:p>
         </p:txBody>
       </p:sp>
@@ -7668,14 +7783,14 @@
           <a:noFill/>
         </p:spPr>
         <p:txBody>
-          <a:bodyPr wrap="none" lIns="0" rIns="0" tIns="0" bIns="0" anchor="t">
+          <a:bodyPr wrap="none" lIns="0" tIns="0" rIns="0" bIns="0" anchor="t">
             <a:spAutoFit/>
           </a:bodyPr>
           <a:lstStyle/>
           <a:p>
             <a:pPr algn="l"/>
             <a:r>
-              <a:rPr b="1" sz="1050" i="0" u="none">
+              <a:rPr sz="1050" b="1" i="0" u="none">
                 <a:solidFill>
                   <a:srgbClr val="E95420"/>
                 </a:solidFill>
@@ -7703,14 +7818,14 @@
           <a:noFill/>
         </p:spPr>
         <p:txBody>
-          <a:bodyPr wrap="none" lIns="0" rIns="0" tIns="0" bIns="0" anchor="t">
+          <a:bodyPr wrap="none" lIns="0" tIns="0" rIns="0" bIns="0" anchor="t">
             <a:spAutoFit/>
           </a:bodyPr>
           <a:lstStyle/>
           <a:p>
             <a:pPr algn="l"/>
             <a:r>
-              <a:rPr b="1" sz="2700" i="0" u="none">
+              <a:rPr sz="2700" b="1" i="0" u="none">
                 <a:solidFill>
                   <a:srgbClr val="0F172A"/>
                 </a:solidFill>
@@ -7738,14 +7853,14 @@
           <a:noFill/>
         </p:spPr>
         <p:txBody>
-          <a:bodyPr wrap="none" lIns="0" rIns="0" tIns="0" bIns="0" anchor="t">
+          <a:bodyPr wrap="none" lIns="0" tIns="0" rIns="0" bIns="0" anchor="t">
             <a:spAutoFit/>
           </a:bodyPr>
           <a:lstStyle/>
           <a:p>
             <a:pPr algn="l"/>
             <a:r>
-              <a:rPr b="1" sz="1650" i="0" u="none">
+              <a:rPr sz="1650" b="1" i="0" u="none">
                 <a:solidFill>
                   <a:srgbClr val="0F172A"/>
                 </a:solidFill>
@@ -7773,7 +7888,7 @@
           <a:noFill/>
         </p:spPr>
         <p:txBody>
-          <a:bodyPr wrap="square" lIns="0" rIns="0" tIns="0" bIns="0" anchor="t">
+          <a:bodyPr wrap="square" lIns="0" tIns="0" rIns="0" bIns="0" anchor="t">
             <a:spAutoFit/>
           </a:bodyPr>
           <a:lstStyle/>
@@ -7784,7 +7899,7 @@
               </a:lnSpc>
             </a:pPr>
             <a:r>
-              <a:rPr b="0" sz="1200" i="0" u="none">
+              <a:rPr sz="1200" b="0" i="0" u="none">
                 <a:solidFill>
                   <a:srgbClr val="475569"/>
                 </a:solidFill>
@@ -7812,14 +7927,14 @@
           <a:noFill/>
         </p:spPr>
         <p:txBody>
-          <a:bodyPr wrap="none" lIns="0" rIns="0" tIns="0" bIns="0" anchor="t">
+          <a:bodyPr wrap="none" lIns="0" tIns="0" rIns="0" bIns="0" anchor="t">
             <a:spAutoFit/>
           </a:bodyPr>
           <a:lstStyle/>
           <a:p>
             <a:pPr algn="l"/>
             <a:r>
-              <a:rPr b="1" sz="1650" i="0" u="none">
+              <a:rPr sz="1650" b="1" i="0" u="none">
                 <a:solidFill>
                   <a:srgbClr val="0F172A"/>
                 </a:solidFill>
@@ -7847,7 +7962,7 @@
           <a:noFill/>
         </p:spPr>
         <p:txBody>
-          <a:bodyPr wrap="square" lIns="0" rIns="0" tIns="0" bIns="0" anchor="t">
+          <a:bodyPr wrap="square" lIns="0" tIns="0" rIns="0" bIns="0" anchor="t">
             <a:spAutoFit/>
           </a:bodyPr>
           <a:lstStyle/>
@@ -7858,7 +7973,7 @@
               </a:lnSpc>
             </a:pPr>
             <a:r>
-              <a:rPr b="0" sz="1200" i="0" u="none">
+              <a:rPr sz="1200" b="0" i="0" u="none">
                 <a:solidFill>
                   <a:srgbClr val="475569"/>
                 </a:solidFill>
@@ -7878,7 +7993,7 @@
 </file>
 
 <file path=ppt/slides/slide8.xml><?xml version="1.0" encoding="utf-8"?>
-<p:sld xmlns:a="http://schemas.openxmlformats.org/drawingml/2006/main" xmlns:p="http://schemas.openxmlformats.org/presentationml/2006/main" xmlns:r="http://schemas.openxmlformats.org/officeDocument/2006/relationships">
+<p:sld xmlns:a="http://schemas.openxmlformats.org/drawingml/2006/main" xmlns:r="http://schemas.openxmlformats.org/officeDocument/2006/relationships" xmlns:p="http://schemas.openxmlformats.org/presentationml/2006/main">
   <p:cSld>
     <p:bg>
       <p:bgPr>
@@ -7894,7 +8009,14 @@
         <p:cNvGrpSpPr/>
         <p:nvPr/>
       </p:nvGrpSpPr>
-      <p:grpSpPr/>
+      <p:grpSpPr>
+        <a:xfrm>
+          <a:off x="0" y="0"/>
+          <a:ext cx="0" cy="0"/>
+          <a:chOff x="0" y="0"/>
+          <a:chExt cx="0" cy="0"/>
+        </a:xfrm>
+      </p:grpSpPr>
       <p:sp>
         <p:nvSpPr>
           <p:cNvPr id="2" name="Rounded Rectangle 1"/>
@@ -7938,6 +8060,7 @@
           <a:lstStyle/>
           <a:p>
             <a:pPr algn="ctr"/>
+            <a:endParaRPr/>
           </a:p>
         </p:txBody>
       </p:sp>
@@ -7984,6 +8107,7 @@
           <a:lstStyle/>
           <a:p>
             <a:pPr algn="ctr"/>
+            <a:endParaRPr/>
           </a:p>
         </p:txBody>
       </p:sp>
@@ -8030,6 +8154,7 @@
           <a:lstStyle/>
           <a:p>
             <a:pPr algn="ctr"/>
+            <a:endParaRPr/>
           </a:p>
         </p:txBody>
       </p:sp>
@@ -8050,14 +8175,14 @@
           <a:noFill/>
         </p:spPr>
         <p:txBody>
-          <a:bodyPr wrap="none" lIns="0" rIns="0" tIns="0" bIns="0" anchor="t">
+          <a:bodyPr wrap="none" lIns="0" tIns="0" rIns="0" bIns="0" anchor="t">
             <a:spAutoFit/>
           </a:bodyPr>
           <a:lstStyle/>
           <a:p>
             <a:pPr algn="l"/>
             <a:r>
-              <a:rPr b="1" sz="1050" i="0" u="none">
+              <a:rPr sz="1050" b="1" i="0" u="none">
                 <a:solidFill>
                   <a:srgbClr val="E95420"/>
                 </a:solidFill>
@@ -8085,14 +8210,14 @@
           <a:noFill/>
         </p:spPr>
         <p:txBody>
-          <a:bodyPr wrap="none" lIns="0" rIns="0" tIns="0" bIns="0" anchor="t">
+          <a:bodyPr wrap="none" lIns="0" tIns="0" rIns="0" bIns="0" anchor="t">
             <a:spAutoFit/>
           </a:bodyPr>
           <a:lstStyle/>
           <a:p>
             <a:pPr algn="l"/>
             <a:r>
-              <a:rPr b="1" sz="2700" i="0" u="none">
+              <a:rPr sz="2700" b="1" i="0" u="none">
                 <a:solidFill>
                   <a:srgbClr val="0F172A"/>
                 </a:solidFill>
@@ -8120,7 +8245,7 @@
           <a:noFill/>
         </p:spPr>
         <p:txBody>
-          <a:bodyPr wrap="none" lIns="0" rIns="0" tIns="0" bIns="0" anchor="t">
+          <a:bodyPr wrap="none" lIns="0" tIns="0" rIns="0" bIns="0" anchor="t">
             <a:spAutoFit/>
           </a:bodyPr>
           <a:lstStyle/>
@@ -8131,7 +8256,7 @@
               </a:lnSpc>
             </a:pPr>
             <a:r>
-              <a:rPr b="1" sz="4800" i="0" u="none">
+              <a:rPr sz="4800" b="1" i="0" u="none">
                 <a:solidFill>
                   <a:srgbClr val="E95420"/>
                 </a:solidFill>
@@ -8159,14 +8284,14 @@
           <a:noFill/>
         </p:spPr>
         <p:txBody>
-          <a:bodyPr wrap="none" lIns="0" rIns="0" tIns="0" bIns="0" anchor="t">
+          <a:bodyPr wrap="none" lIns="0" tIns="0" rIns="0" bIns="0" anchor="t">
             <a:spAutoFit/>
           </a:bodyPr>
           <a:lstStyle/>
           <a:p>
             <a:pPr algn="ctr"/>
             <a:r>
-              <a:rPr b="1" sz="1350" i="0" u="none">
+              <a:rPr sz="1350" b="1" i="0" u="none">
                 <a:solidFill>
                   <a:srgbClr val="0F172A"/>
                 </a:solidFill>
@@ -8194,14 +8319,14 @@
           <a:noFill/>
         </p:spPr>
         <p:txBody>
-          <a:bodyPr wrap="none" lIns="0" rIns="0" tIns="0" bIns="0" anchor="t">
+          <a:bodyPr wrap="none" lIns="0" tIns="0" rIns="0" bIns="0" anchor="t">
             <a:spAutoFit/>
           </a:bodyPr>
           <a:lstStyle/>
           <a:p>
             <a:pPr algn="ctr"/>
             <a:r>
-              <a:rPr b="0" sz="1050" i="0" u="none">
+              <a:rPr sz="1050" b="0" i="0" u="none">
                 <a:solidFill>
                   <a:srgbClr val="64748B"/>
                 </a:solidFill>
@@ -8229,7 +8354,7 @@
           <a:noFill/>
         </p:spPr>
         <p:txBody>
-          <a:bodyPr wrap="none" lIns="0" rIns="0" tIns="0" bIns="0" anchor="t">
+          <a:bodyPr wrap="none" lIns="0" tIns="0" rIns="0" bIns="0" anchor="t">
             <a:spAutoFit/>
           </a:bodyPr>
           <a:lstStyle/>
@@ -8240,7 +8365,7 @@
               </a:lnSpc>
             </a:pPr>
             <a:r>
-              <a:rPr b="1" sz="4800" i="0" u="none">
+              <a:rPr sz="4800" b="1" i="0" u="none">
                 <a:solidFill>
                   <a:srgbClr val="77216F"/>
                 </a:solidFill>
@@ -8268,14 +8393,14 @@
           <a:noFill/>
         </p:spPr>
         <p:txBody>
-          <a:bodyPr wrap="none" lIns="0" rIns="0" tIns="0" bIns="0" anchor="t">
+          <a:bodyPr wrap="none" lIns="0" tIns="0" rIns="0" bIns="0" anchor="t">
             <a:spAutoFit/>
           </a:bodyPr>
           <a:lstStyle/>
           <a:p>
             <a:pPr algn="ctr"/>
             <a:r>
-              <a:rPr b="1" sz="1350" i="0" u="none">
+              <a:rPr sz="1350" b="1" i="0" u="none">
                 <a:solidFill>
                   <a:srgbClr val="0F172A"/>
                 </a:solidFill>
@@ -8303,14 +8428,14 @@
           <a:noFill/>
         </p:spPr>
         <p:txBody>
-          <a:bodyPr wrap="square" lIns="0" rIns="0" tIns="0" bIns="0" anchor="t">
+          <a:bodyPr wrap="square" lIns="0" tIns="0" rIns="0" bIns="0" anchor="t">
             <a:spAutoFit/>
           </a:bodyPr>
           <a:lstStyle/>
           <a:p>
             <a:pPr algn="ctr"/>
             <a:r>
-              <a:rPr b="0" sz="1050" i="0" u="none">
+              <a:rPr sz="1050" b="0" i="0" u="none">
                 <a:solidFill>
                   <a:srgbClr val="64748B"/>
                 </a:solidFill>
@@ -8338,7 +8463,7 @@
           <a:noFill/>
         </p:spPr>
         <p:txBody>
-          <a:bodyPr wrap="none" lIns="0" rIns="0" tIns="0" bIns="0" anchor="t">
+          <a:bodyPr wrap="none" lIns="0" tIns="0" rIns="0" bIns="0" anchor="t">
             <a:spAutoFit/>
           </a:bodyPr>
           <a:lstStyle/>
@@ -8349,7 +8474,7 @@
               </a:lnSpc>
             </a:pPr>
             <a:r>
-              <a:rPr b="1" sz="4800" i="0" u="none">
+              <a:rPr sz="4800" b="1" i="0" u="none">
                 <a:solidFill>
                   <a:srgbClr val="E95420"/>
                 </a:solidFill>
@@ -8377,14 +8502,14 @@
           <a:noFill/>
         </p:spPr>
         <p:txBody>
-          <a:bodyPr wrap="none" lIns="0" rIns="0" tIns="0" bIns="0" anchor="t">
+          <a:bodyPr wrap="none" lIns="0" tIns="0" rIns="0" bIns="0" anchor="t">
             <a:spAutoFit/>
           </a:bodyPr>
           <a:lstStyle/>
           <a:p>
             <a:pPr algn="ctr"/>
             <a:r>
-              <a:rPr b="1" sz="1350" i="0" u="none">
+              <a:rPr sz="1350" b="1" i="0" u="none">
                 <a:solidFill>
                   <a:srgbClr val="0F172A"/>
                 </a:solidFill>
@@ -8412,14 +8537,14 @@
           <a:noFill/>
         </p:spPr>
         <p:txBody>
-          <a:bodyPr wrap="none" lIns="0" rIns="0" tIns="0" bIns="0" anchor="t">
+          <a:bodyPr wrap="none" lIns="0" tIns="0" rIns="0" bIns="0" anchor="t">
             <a:spAutoFit/>
           </a:bodyPr>
           <a:lstStyle/>
           <a:p>
             <a:pPr algn="ctr"/>
             <a:r>
-              <a:rPr b="0" sz="1050" i="0" u="none">
+              <a:rPr sz="1050" b="0" i="0" u="none">
                 <a:solidFill>
                   <a:srgbClr val="64748B"/>
                 </a:solidFill>
@@ -8439,7 +8564,7 @@
 </file>
 
 <file path=ppt/slides/slide9.xml><?xml version="1.0" encoding="utf-8"?>
-<p:sld xmlns:a="http://schemas.openxmlformats.org/drawingml/2006/main" xmlns:p="http://schemas.openxmlformats.org/presentationml/2006/main" xmlns:r="http://schemas.openxmlformats.org/officeDocument/2006/relationships">
+<p:sld xmlns:a="http://schemas.openxmlformats.org/drawingml/2006/main" xmlns:r="http://schemas.openxmlformats.org/officeDocument/2006/relationships" xmlns:p="http://schemas.openxmlformats.org/presentationml/2006/main">
   <p:cSld>
     <p:bg>
       <p:bgPr>
@@ -8455,7 +8580,14 @@
         <p:cNvGrpSpPr/>
         <p:nvPr/>
       </p:nvGrpSpPr>
-      <p:grpSpPr/>
+      <p:grpSpPr>
+        <a:xfrm>
+          <a:off x="0" y="0"/>
+          <a:ext cx="0" cy="0"/>
+          <a:chOff x="0" y="0"/>
+          <a:chExt cx="0" cy="0"/>
+        </a:xfrm>
+      </p:grpSpPr>
       <p:sp>
         <p:nvSpPr>
           <p:cNvPr id="2" name="Rounded Rectangle 1"/>
@@ -8499,6 +8631,7 @@
           <a:lstStyle/>
           <a:p>
             <a:pPr algn="ctr"/>
+            <a:endParaRPr/>
           </a:p>
         </p:txBody>
       </p:sp>
@@ -8545,6 +8678,7 @@
           <a:lstStyle/>
           <a:p>
             <a:pPr algn="ctr"/>
+            <a:endParaRPr/>
           </a:p>
         </p:txBody>
       </p:sp>
@@ -8591,6 +8725,7 @@
           <a:lstStyle/>
           <a:p>
             <a:pPr algn="ctr"/>
+            <a:endParaRPr/>
           </a:p>
         </p:txBody>
       </p:sp>
@@ -8637,6 +8772,7 @@
           <a:lstStyle/>
           <a:p>
             <a:pPr algn="ctr"/>
+            <a:endParaRPr/>
           </a:p>
         </p:txBody>
       </p:sp>
@@ -8657,14 +8793,14 @@
           <a:noFill/>
         </p:spPr>
         <p:txBody>
-          <a:bodyPr wrap="none" lIns="0" rIns="0" tIns="0" bIns="0" anchor="t">
+          <a:bodyPr wrap="none" lIns="0" tIns="0" rIns="0" bIns="0" anchor="t">
             <a:spAutoFit/>
           </a:bodyPr>
           <a:lstStyle/>
           <a:p>
             <a:pPr algn="l"/>
             <a:r>
-              <a:rPr b="1" sz="1050" i="0" u="none">
+              <a:rPr sz="1050" b="1" i="0" u="none">
                 <a:solidFill>
                   <a:srgbClr val="E95420"/>
                 </a:solidFill>
@@ -8692,14 +8828,14 @@
           <a:noFill/>
         </p:spPr>
         <p:txBody>
-          <a:bodyPr wrap="none" lIns="0" rIns="0" tIns="0" bIns="0" anchor="t">
+          <a:bodyPr wrap="none" lIns="0" tIns="0" rIns="0" bIns="0" anchor="t">
             <a:spAutoFit/>
           </a:bodyPr>
           <a:lstStyle/>
           <a:p>
             <a:pPr algn="l"/>
             <a:r>
-              <a:rPr b="1" sz="2700" i="0" u="none">
+              <a:rPr sz="2700" b="1" i="0" u="none">
                 <a:solidFill>
                   <a:srgbClr val="0F172A"/>
                 </a:solidFill>
@@ -8727,14 +8863,14 @@
           <a:noFill/>
         </p:spPr>
         <p:txBody>
-          <a:bodyPr wrap="none" lIns="0" rIns="0" tIns="0" bIns="0" anchor="t">
+          <a:bodyPr wrap="none" lIns="0" tIns="0" rIns="0" bIns="0" anchor="t">
             <a:spAutoFit/>
           </a:bodyPr>
           <a:lstStyle/>
           <a:p>
             <a:pPr algn="l"/>
             <a:r>
-              <a:rPr b="1" sz="1350" i="0" u="none">
+              <a:rPr sz="1350" b="1" i="0" u="none">
                 <a:solidFill>
                   <a:srgbClr val="0F172A"/>
                 </a:solidFill>
@@ -8762,14 +8898,14 @@
           <a:noFill/>
         </p:spPr>
         <p:txBody>
-          <a:bodyPr wrap="square" lIns="0" rIns="0" tIns="0" bIns="0" anchor="t">
+          <a:bodyPr wrap="square" lIns="0" tIns="0" rIns="0" bIns="0" anchor="t">
             <a:spAutoFit/>
           </a:bodyPr>
           <a:lstStyle/>
           <a:p>
             <a:pPr algn="l"/>
             <a:r>
-              <a:rPr b="0" sz="1125" i="0" u="none">
+              <a:rPr sz="1125" b="0" i="0" u="none">
                 <a:solidFill>
                   <a:srgbClr val="475569"/>
                 </a:solidFill>
@@ -8797,14 +8933,14 @@
           <a:noFill/>
         </p:spPr>
         <p:txBody>
-          <a:bodyPr wrap="none" lIns="0" rIns="0" tIns="0" bIns="0" anchor="t">
+          <a:bodyPr wrap="none" lIns="0" tIns="0" rIns="0" bIns="0" anchor="t">
             <a:spAutoFit/>
           </a:bodyPr>
           <a:lstStyle/>
           <a:p>
             <a:pPr algn="l"/>
             <a:r>
-              <a:rPr b="1" sz="1350" i="0" u="none">
+              <a:rPr sz="1350" b="1" i="0" u="none">
                 <a:solidFill>
                   <a:srgbClr val="0F172A"/>
                 </a:solidFill>
@@ -8832,14 +8968,14 @@
           <a:noFill/>
         </p:spPr>
         <p:txBody>
-          <a:bodyPr wrap="square" lIns="0" rIns="0" tIns="0" bIns="0" anchor="t">
+          <a:bodyPr wrap="square" lIns="0" tIns="0" rIns="0" bIns="0" anchor="t">
             <a:spAutoFit/>
           </a:bodyPr>
           <a:lstStyle/>
           <a:p>
             <a:pPr algn="l"/>
             <a:r>
-              <a:rPr b="0" sz="1125" i="0" u="none">
+              <a:rPr sz="1125" b="0" i="0" u="none">
                 <a:solidFill>
                   <a:srgbClr val="475569"/>
                 </a:solidFill>
@@ -8867,14 +9003,14 @@
           <a:noFill/>
         </p:spPr>
         <p:txBody>
-          <a:bodyPr wrap="none" lIns="0" rIns="0" tIns="0" bIns="0" anchor="t">
+          <a:bodyPr wrap="none" lIns="0" tIns="0" rIns="0" bIns="0" anchor="t">
             <a:spAutoFit/>
           </a:bodyPr>
           <a:lstStyle/>
           <a:p>
             <a:pPr algn="l"/>
             <a:r>
-              <a:rPr b="1" sz="1350" i="0" u="none">
+              <a:rPr sz="1350" b="1" i="0" u="none">
                 <a:solidFill>
                   <a:srgbClr val="0F172A"/>
                 </a:solidFill>
@@ -8902,14 +9038,14 @@
           <a:noFill/>
         </p:spPr>
         <p:txBody>
-          <a:bodyPr wrap="square" lIns="0" rIns="0" tIns="0" bIns="0" anchor="t">
+          <a:bodyPr wrap="square" lIns="0" tIns="0" rIns="0" bIns="0" anchor="t">
             <a:spAutoFit/>
           </a:bodyPr>
           <a:lstStyle/>
           <a:p>
             <a:pPr algn="l"/>
             <a:r>
-              <a:rPr b="0" sz="1125" i="0" u="none">
+              <a:rPr sz="1125" b="0" i="0" u="none">
                 <a:solidFill>
                   <a:srgbClr val="475569"/>
                 </a:solidFill>
@@ -8937,14 +9073,14 @@
           <a:noFill/>
         </p:spPr>
         <p:txBody>
-          <a:bodyPr wrap="none" lIns="0" rIns="0" tIns="0" bIns="0" anchor="t">
+          <a:bodyPr wrap="none" lIns="0" tIns="0" rIns="0" bIns="0" anchor="t">
             <a:spAutoFit/>
           </a:bodyPr>
           <a:lstStyle/>
           <a:p>
             <a:pPr algn="l"/>
             <a:r>
-              <a:rPr b="1" sz="1350" i="0" u="none">
+              <a:rPr sz="1350" b="1" i="0" u="none">
                 <a:solidFill>
                   <a:srgbClr val="0F172A"/>
                 </a:solidFill>
@@ -8972,14 +9108,14 @@
           <a:noFill/>
         </p:spPr>
         <p:txBody>
-          <a:bodyPr wrap="square" lIns="0" rIns="0" tIns="0" bIns="0" anchor="t">
+          <a:bodyPr wrap="square" lIns="0" tIns="0" rIns="0" bIns="0" anchor="t">
             <a:spAutoFit/>
           </a:bodyPr>
           <a:lstStyle/>
           <a:p>
             <a:pPr algn="l"/>
             <a:r>
-              <a:rPr b="0" sz="1125" i="0" u="none">
+              <a:rPr sz="1125" b="0" i="0" u="none">
                 <a:solidFill>
                   <a:srgbClr val="475569"/>
                 </a:solidFill>

</xml_diff>